<commit_message>
Add project, tech stack, scenario and development flow diagrams to evaluation deck
</commit_message>
<xml_diff>
--- a/rsp/ppt/SkillBridge_Evaluation.pptx
+++ b/rsp/ppt/SkillBridge_Evaluation.pptx
@@ -28,9 +28,12 @@
     <p:sldId id="276" r:id="rId22"/>
     <p:sldId id="277" r:id="rId23"/>
     <p:sldId id="278" r:id="rId24"/>
+    <p:sldId id="279" r:id="rId25"/>
+    <p:sldId id="280" r:id="rId26"/>
+    <p:sldId id="281" r:id="rId27"/>
   </p:sldIdLst>
   <p:notesMasterIdLst>
-    <p:notesMasterId r:id="rId25"/>
+    <p:notesMasterId r:id="rId28"/>
   </p:notesMasterIdLst>
   <p:sldSz cx="9144000" cy="5143500"/>
   <p:notesSz cx="5143500" cy="9144000"/>
@@ -129,7 +132,7 @@
   <p:extLst>
     <p:ext uri="{521415D9-36F7-43E2-AB2F-B90AF26B5E84}">
       <p14:sectionLst xmlns:p14="http://schemas.microsoft.com/office/powerpoint/2010/main">
-        <p14:section name="Introduction" id="{a9ec9b7d-b135-6514-ce3f-2025d3970b0d}">
+        <p14:section name="Introduction" id="{8061075b-f526-9a2f-ae94-61a212bf8797}">
           <p14:sldIdLst>
             <p14:sldId id="256"/>
             <p14:sldId id="257"/>
@@ -137,47 +140,50 @@
             <p14:sldId id="259"/>
           </p14:sldIdLst>
         </p14:section>
-        <p14:section name="Data &amp; architecture" id="{141c5e46-c136-f039-e2cb-bdac5963021f}">
+        <p14:section name="Data &amp; architecture" id="{4ced18a0-7176-3b57-f013-e93a0fdd2e6d}">
           <p14:sldIdLst>
             <p14:sldId id="260"/>
             <p14:sldId id="261"/>
             <p14:sldId id="262"/>
+            <p14:sldId id="263"/>
           </p14:sldIdLst>
         </p14:section>
-        <p14:section name="Methodology" id="{faf3c11e-53bc-fd5f-7600-bb4c6c959917}">
+        <p14:section name="Methodology" id="{4538e13f-65e0-69a0-9764-9257ace4a8fd}">
           <p14:sldIdLst>
-            <p14:sldId id="263"/>
             <p14:sldId id="264"/>
             <p14:sldId id="265"/>
+            <p14:sldId id="266"/>
           </p14:sldIdLst>
         </p14:section>
-        <p14:section name="Results" id="{129337fe-b42d-11d1-acfb-7f6b05f0ce79}">
+        <p14:section name="Results" id="{629e1114-2a3a-482e-4b5c-22eb402e344d}">
           <p14:sldIdLst>
-            <p14:sldId id="266"/>
             <p14:sldId id="267"/>
+            <p14:sldId id="268"/>
           </p14:sldIdLst>
         </p14:section>
-        <p14:section name="Live system" id="{46561714-6c1c-c363-c3d7-c225351c925c}">
+        <p14:section name="Live system" id="{fd599bef-c590-62db-75bf-c7e3fa407ee6}">
           <p14:sldIdLst>
-            <p14:sldId id="268"/>
             <p14:sldId id="269"/>
             <p14:sldId id="270"/>
             <p14:sldId id="271"/>
             <p14:sldId id="272"/>
             <p14:sldId id="273"/>
-          </p14:sldIdLst>
-        </p14:section>
-        <p14:section name="Testing &amp; quality" id="{0dc5d3cf-dacd-c8a9-fff6-c630fa9dc150}">
-          <p14:sldIdLst>
             <p14:sldId id="274"/>
             <p14:sldId id="275"/>
           </p14:sldIdLst>
         </p14:section>
-        <p14:section name="Conclusion" id="{3aa5e7cc-b38e-f14a-4e16-39007e8e34b6}">
+        <p14:section name="Testing &amp; quality" id="{0e0f8941-c23c-8c7a-580d-6573942de2ee}">
           <p14:sldIdLst>
             <p14:sldId id="276"/>
             <p14:sldId id="277"/>
             <p14:sldId id="278"/>
+          </p14:sldIdLst>
+        </p14:section>
+        <p14:section name="Conclusion" id="{bd09b1a1-3d76-576c-5e99-3adafc4ce8ec}">
+          <p14:sldIdLst>
+            <p14:sldId id="279"/>
+            <p14:sldId id="280"/>
+            <p14:sldId id="281"/>
           </p14:sldIdLst>
         </p14:section>
       </p14:sectionLst>
@@ -1969,7 +1975,7 @@
           <a:p>
             <a:r>
               <a:rPr lang="en-US" dirty="0"/>
-              <a:t>On the real data, adding skills lowers the estimate — the dashboard says so and explains why, rather than hiding it.</a:t>
+              <a:t/>
             </a:r>
             <a:endParaRPr lang="en-US" dirty="0"/>
           </a:p>
@@ -2145,7 +2151,7 @@
           <a:p>
             <a:r>
               <a:rPr lang="en-US" dirty="0"/>
-              <a:t/>
+              <a:t>On the real data, adding skills lowers the estimate — the dashboard says so and explains why, rather than hiding it.</a:t>
             </a:r>
             <a:endParaRPr lang="en-US" dirty="0"/>
           </a:p>
@@ -2873,6 +2879,270 @@
             <a:fld id="{F7021451-1387-4CA6-816F-3879F97B5CBC}" type="slidenum">
               <a:rPr lang="en-US"/>
               <a:t>23</a:t>
+            </a:fld>
+            <a:endParaRPr lang="en-US"/>
+          </a:p>
+        </p:txBody>
+      </p:sp>
+    </p:spTree>
+    <p:extLst>
+      <p:ext uri="{BB962C8B-B14F-4D97-AF65-F5344CB8AC3E}">
+        <p14:creationId xmlns:p14="http://schemas.microsoft.com/office/powerpoint/2010/main" val="1024086991"/>
+      </p:ext>
+    </p:extLst>
+  </p:cSld>
+  <p:clrMapOvr>
+    <a:masterClrMapping/>
+  </p:clrMapOvr>
+</p:notes>
+</file>
+
+<file path=ppt/notesSlides/notesSlide24.xml><?xml version="1.0" encoding="utf-8"?>
+<p:notes xmlns:a="http://schemas.openxmlformats.org/drawingml/2006/main" xmlns:r="http://schemas.openxmlformats.org/officeDocument/2006/relationships" xmlns:p="http://schemas.openxmlformats.org/presentationml/2006/main">
+  <p:cSld>
+    <p:spTree>
+      <p:nvGrpSpPr>
+        <p:cNvPr id="1" name=""/>
+        <p:cNvGrpSpPr/>
+        <p:nvPr/>
+      </p:nvGrpSpPr>
+      <p:grpSpPr>
+        <a:xfrm>
+          <a:off x="0" y="0"/>
+          <a:ext cx="0" cy="0"/>
+          <a:chOff x="0" y="0"/>
+          <a:chExt cx="0" cy="0"/>
+        </a:xfrm>
+      </p:grpSpPr>
+      <p:sp>
+        <p:nvSpPr>
+          <p:cNvPr id="2" name="Slide Image Placeholder 1"/>
+          <p:cNvSpPr>
+            <a:spLocks noGrp="1" noRot="1" noChangeAspect="1"/>
+          </p:cNvSpPr>
+          <p:nvPr>
+            <p:ph type="sldImg"/>
+          </p:nvPr>
+        </p:nvSpPr>
+        <p:spPr/>
+      </p:sp>
+      <p:sp>
+        <p:nvSpPr>
+          <p:cNvPr id="3" name="Notes Placeholder 2"/>
+          <p:cNvSpPr>
+            <a:spLocks noGrp="1"/>
+          </p:cNvSpPr>
+          <p:nvPr>
+            <p:ph type="body" idx="1"/>
+          </p:nvPr>
+        </p:nvSpPr>
+        <p:spPr/>
+        <p:txBody>
+          <a:bodyPr/>
+          <a:lstStyle/>
+          <a:p>
+            <a:r>
+              <a:rPr lang="en-US" dirty="0"/>
+              <a:t/>
+            </a:r>
+            <a:endParaRPr lang="en-US" dirty="0"/>
+          </a:p>
+        </p:txBody>
+      </p:sp>
+      <p:sp>
+        <p:nvSpPr>
+          <p:cNvPr id="4" name="Slide Number Placeholder 3"/>
+          <p:cNvSpPr>
+            <a:spLocks noGrp="1"/>
+          </p:cNvSpPr>
+          <p:nvPr>
+            <p:ph type="sldNum" sz="quarter" idx="10"/>
+          </p:nvPr>
+        </p:nvSpPr>
+        <p:spPr/>
+        <p:txBody>
+          <a:bodyPr/>
+          <a:lstStyle/>
+          <a:p>
+            <a:fld id="{F7021451-1387-4CA6-816F-3879F97B5CBC}" type="slidenum">
+              <a:rPr lang="en-US"/>
+              <a:t>24</a:t>
+            </a:fld>
+            <a:endParaRPr lang="en-US"/>
+          </a:p>
+        </p:txBody>
+      </p:sp>
+    </p:spTree>
+    <p:extLst>
+      <p:ext uri="{BB962C8B-B14F-4D97-AF65-F5344CB8AC3E}">
+        <p14:creationId xmlns:p14="http://schemas.microsoft.com/office/powerpoint/2010/main" val="1024086991"/>
+      </p:ext>
+    </p:extLst>
+  </p:cSld>
+  <p:clrMapOvr>
+    <a:masterClrMapping/>
+  </p:clrMapOvr>
+</p:notes>
+</file>
+
+<file path=ppt/notesSlides/notesSlide25.xml><?xml version="1.0" encoding="utf-8"?>
+<p:notes xmlns:a="http://schemas.openxmlformats.org/drawingml/2006/main" xmlns:r="http://schemas.openxmlformats.org/officeDocument/2006/relationships" xmlns:p="http://schemas.openxmlformats.org/presentationml/2006/main">
+  <p:cSld>
+    <p:spTree>
+      <p:nvGrpSpPr>
+        <p:cNvPr id="1" name=""/>
+        <p:cNvGrpSpPr/>
+        <p:nvPr/>
+      </p:nvGrpSpPr>
+      <p:grpSpPr>
+        <a:xfrm>
+          <a:off x="0" y="0"/>
+          <a:ext cx="0" cy="0"/>
+          <a:chOff x="0" y="0"/>
+          <a:chExt cx="0" cy="0"/>
+        </a:xfrm>
+      </p:grpSpPr>
+      <p:sp>
+        <p:nvSpPr>
+          <p:cNvPr id="2" name="Slide Image Placeholder 1"/>
+          <p:cNvSpPr>
+            <a:spLocks noGrp="1" noRot="1" noChangeAspect="1"/>
+          </p:cNvSpPr>
+          <p:nvPr>
+            <p:ph type="sldImg"/>
+          </p:nvPr>
+        </p:nvSpPr>
+        <p:spPr/>
+      </p:sp>
+      <p:sp>
+        <p:nvSpPr>
+          <p:cNvPr id="3" name="Notes Placeholder 2"/>
+          <p:cNvSpPr>
+            <a:spLocks noGrp="1"/>
+          </p:cNvSpPr>
+          <p:nvPr>
+            <p:ph type="body" idx="1"/>
+          </p:nvPr>
+        </p:nvSpPr>
+        <p:spPr/>
+        <p:txBody>
+          <a:bodyPr/>
+          <a:lstStyle/>
+          <a:p>
+            <a:r>
+              <a:rPr lang="en-US" dirty="0"/>
+              <a:t/>
+            </a:r>
+            <a:endParaRPr lang="en-US" dirty="0"/>
+          </a:p>
+        </p:txBody>
+      </p:sp>
+      <p:sp>
+        <p:nvSpPr>
+          <p:cNvPr id="4" name="Slide Number Placeholder 3"/>
+          <p:cNvSpPr>
+            <a:spLocks noGrp="1"/>
+          </p:cNvSpPr>
+          <p:nvPr>
+            <p:ph type="sldNum" sz="quarter" idx="10"/>
+          </p:nvPr>
+        </p:nvSpPr>
+        <p:spPr/>
+        <p:txBody>
+          <a:bodyPr/>
+          <a:lstStyle/>
+          <a:p>
+            <a:fld id="{F7021451-1387-4CA6-816F-3879F97B5CBC}" type="slidenum">
+              <a:rPr lang="en-US"/>
+              <a:t>25</a:t>
+            </a:fld>
+            <a:endParaRPr lang="en-US"/>
+          </a:p>
+        </p:txBody>
+      </p:sp>
+    </p:spTree>
+    <p:extLst>
+      <p:ext uri="{BB962C8B-B14F-4D97-AF65-F5344CB8AC3E}">
+        <p14:creationId xmlns:p14="http://schemas.microsoft.com/office/powerpoint/2010/main" val="1024086991"/>
+      </p:ext>
+    </p:extLst>
+  </p:cSld>
+  <p:clrMapOvr>
+    <a:masterClrMapping/>
+  </p:clrMapOvr>
+</p:notes>
+</file>
+
+<file path=ppt/notesSlides/notesSlide26.xml><?xml version="1.0" encoding="utf-8"?>
+<p:notes xmlns:a="http://schemas.openxmlformats.org/drawingml/2006/main" xmlns:r="http://schemas.openxmlformats.org/officeDocument/2006/relationships" xmlns:p="http://schemas.openxmlformats.org/presentationml/2006/main">
+  <p:cSld>
+    <p:spTree>
+      <p:nvGrpSpPr>
+        <p:cNvPr id="1" name=""/>
+        <p:cNvGrpSpPr/>
+        <p:nvPr/>
+      </p:nvGrpSpPr>
+      <p:grpSpPr>
+        <a:xfrm>
+          <a:off x="0" y="0"/>
+          <a:ext cx="0" cy="0"/>
+          <a:chOff x="0" y="0"/>
+          <a:chExt cx="0" cy="0"/>
+        </a:xfrm>
+      </p:grpSpPr>
+      <p:sp>
+        <p:nvSpPr>
+          <p:cNvPr id="2" name="Slide Image Placeholder 1"/>
+          <p:cNvSpPr>
+            <a:spLocks noGrp="1" noRot="1" noChangeAspect="1"/>
+          </p:cNvSpPr>
+          <p:nvPr>
+            <p:ph type="sldImg"/>
+          </p:nvPr>
+        </p:nvSpPr>
+        <p:spPr/>
+      </p:sp>
+      <p:sp>
+        <p:nvSpPr>
+          <p:cNvPr id="3" name="Notes Placeholder 2"/>
+          <p:cNvSpPr>
+            <a:spLocks noGrp="1"/>
+          </p:cNvSpPr>
+          <p:nvPr>
+            <p:ph type="body" idx="1"/>
+          </p:nvPr>
+        </p:nvSpPr>
+        <p:spPr/>
+        <p:txBody>
+          <a:bodyPr/>
+          <a:lstStyle/>
+          <a:p>
+            <a:r>
+              <a:rPr lang="en-US" dirty="0"/>
+              <a:t/>
+            </a:r>
+            <a:endParaRPr lang="en-US" dirty="0"/>
+          </a:p>
+        </p:txBody>
+      </p:sp>
+      <p:sp>
+        <p:nvSpPr>
+          <p:cNvPr id="4" name="Slide Number Placeholder 3"/>
+          <p:cNvSpPr>
+            <a:spLocks noGrp="1"/>
+          </p:cNvSpPr>
+          <p:nvPr>
+            <p:ph type="sldNum" sz="quarter" idx="10"/>
+          </p:nvPr>
+        </p:nvSpPr>
+        <p:spPr/>
+        <p:txBody>
+          <a:bodyPr/>
+          <a:lstStyle/>
+          <a:p>
+            <a:fld id="{F7021451-1387-4CA6-816F-3879F97B5CBC}" type="slidenum">
+              <a:rPr lang="en-US"/>
+              <a:t>26</a:t>
             </a:fld>
             <a:endParaRPr lang="en-US"/>
           </a:p>
@@ -4315,7 +4585,7 @@
                   <a:schemeClr val="tx2"/>
                 </a:solidFill>
               </a:rPr>
-              <a:t>Placement prediction model</a:t>
+              <a:t>Market demand &amp; alignment score</a:t>
             </a:r>
             <a:endParaRPr lang="en-US" sz="2800" dirty="0"/>
           </a:p>
@@ -4323,14 +4593,36 @@
       </p:sp>
       <p:sp>
         <p:nvSpPr>
-          <p:cNvPr id="3" name="Text 1"/>
+          <p:cNvPr id="3" name="Shape 1"/>
+          <p:cNvSpPr/>
+          <p:nvPr/>
+        </p:nvSpPr>
+        <p:spPr>
+          <a:xfrm>
+            <a:off x="457200" y="1143000"/>
+            <a:ext cx="3566160" cy="3337560"/>
+          </a:xfrm>
+          <a:prstGeom prst="roundRect">
+            <a:avLst>
+              <a:gd name="adj" fmla="val 3288"/>
+            </a:avLst>
+          </a:prstGeom>
+          <a:solidFill>
+            <a:schemeClr val="bg2"/>
+          </a:solidFill>
+          <a:ln/>
+        </p:spPr>
+      </p:sp>
+      <p:sp>
+        <p:nvSpPr>
+          <p:cNvPr id="4" name="Text 2"/>
           <p:cNvSpPr txBox="1"/>
           <p:nvPr/>
         </p:nvSpPr>
         <p:spPr>
           <a:xfrm>
-            <a:off x="457200" y="1143000"/>
-            <a:ext cx="3657600" cy="3291840"/>
+            <a:off x="685800" y="1325880"/>
+            <a:ext cx="3154680" cy="3017520"/>
           </a:xfrm>
           <a:prstGeom prst="rect">
             <a:avLst/>
@@ -4342,88 +4634,114 @@
           <a:bodyPr wrap="square" lIns="0" tIns="0" rIns="0" bIns="0" rtlCol="0" anchor="t"/>
           <a:lstStyle/>
           <a:p>
-            <a:pPr marL="342900" indent="-342900">
-              <a:spcAft>
-                <a:spcPts val="800"/>
-              </a:spcAft>
-              <a:buSzPct val="100000"/>
-              <a:buChar char="•"/>
-            </a:pPr>
-            <a:r>
-              <a:rPr lang="en-US" sz="1400" dirty="0">
+            <a:pPr indent="0" marL="0">
+              <a:buNone/>
+            </a:pPr>
+            <a:r>
+              <a:rPr lang="en-US" sz="1300" b="1" dirty="0">
+                <a:solidFill>
+                  <a:schemeClr val="accent1"/>
+                </a:solidFill>
+              </a:rPr>
+              <a:t>Demand of a skill</a:t>
+            </a:r>
+            <a:endParaRPr lang="en-US" sz="1300" dirty="0"/>
+          </a:p>
+          <a:p>
+            <a:pPr indent="0" marL="0">
+              <a:buNone/>
+            </a:pPr>
+            <a:r>
+              <a:rPr lang="en-US" sz="1300" dirty="0">
                 <a:solidFill>
                   <a:schemeClr val="tx1"/>
                 </a:solidFill>
               </a:rPr>
-              <a:t>6 features: CGPA, projects, certifications, internships, skill count, alignment score</a:t>
-            </a:r>
-            <a:endParaRPr lang="en-US" sz="1400" dirty="0"/>
-          </a:p>
-          <a:p>
-            <a:pPr marL="342900" indent="-342900">
-              <a:spcAft>
-                <a:spcPts val="800"/>
-              </a:spcAft>
-              <a:buSzPct val="100000"/>
-              <a:buChar char="•"/>
-            </a:pPr>
-            <a:r>
-              <a:rPr lang="en-US" sz="1400" dirty="0">
+              <a:t>d(s) = postings mentioning s ÷ all postings</a:t>
+            </a:r>
+            <a:endParaRPr lang="en-US" sz="1300" dirty="0"/>
+          </a:p>
+          <a:p>
+            <a:pPr indent="0" marL="0">
+              <a:buNone/>
+            </a:pPr>
+            <a:r>
+              <a:rPr lang="en-US" sz="1300" dirty="0">
                 <a:solidFill>
                   <a:schemeClr val="tx1"/>
                 </a:solidFill>
               </a:rPr>
-              <a:t>Standardised; 75/25 stratified split, fixed seed</a:t>
-            </a:r>
-            <a:endParaRPr lang="en-US" sz="1400" dirty="0"/>
-          </a:p>
-          <a:p>
-            <a:pPr marL="342900" indent="-342900">
-              <a:spcAft>
-                <a:spcPts val="800"/>
-              </a:spcAft>
-              <a:buSzPct val="100000"/>
-              <a:buChar char="•"/>
-            </a:pPr>
-            <a:r>
-              <a:rPr lang="en-US" sz="1400" dirty="0">
+              <a:t> </a:t>
+            </a:r>
+            <a:endParaRPr lang="en-US" sz="1300" dirty="0"/>
+          </a:p>
+          <a:p>
+            <a:pPr indent="0" marL="0">
+              <a:buNone/>
+            </a:pPr>
+            <a:r>
+              <a:rPr lang="en-US" sz="1300" b="1" dirty="0">
+                <a:solidFill>
+                  <a:schemeClr val="accent1"/>
+                </a:solidFill>
+              </a:rPr>
+              <a:t>Student alignment</a:t>
+            </a:r>
+            <a:endParaRPr lang="en-US" sz="1300" dirty="0"/>
+          </a:p>
+          <a:p>
+            <a:pPr indent="0" marL="0">
+              <a:buNone/>
+            </a:pPr>
+            <a:r>
+              <a:rPr lang="en-US" sz="1300" dirty="0">
                 <a:solidFill>
                   <a:schemeClr val="tx1"/>
                 </a:solidFill>
               </a:rPr>
-              <a:t>Logistic regression vs XGBoost — higher held-out ROC AUC is kept</a:t>
-            </a:r>
-            <a:endParaRPr lang="en-US" sz="1400" dirty="0"/>
-          </a:p>
-          <a:p>
-            <a:pPr marL="342900" indent="-342900">
-              <a:spcAft>
-                <a:spcPts val="800"/>
-              </a:spcAft>
-              <a:buSzPct val="100000"/>
-              <a:buChar char="•"/>
-            </a:pPr>
-            <a:r>
-              <a:rPr lang="en-US" sz="1400" dirty="0">
+              <a:t>A(u) = Σ d(s) over the student's skills ÷ Σ d(s) over all skills</a:t>
+            </a:r>
+            <a:endParaRPr lang="en-US" sz="1300" dirty="0"/>
+          </a:p>
+          <a:p>
+            <a:pPr indent="0" marL="0">
+              <a:buNone/>
+            </a:pPr>
+            <a:r>
+              <a:rPr lang="en-US" sz="1300" dirty="0">
                 <a:solidFill>
                   <a:schemeClr val="tx1"/>
                 </a:solidFill>
               </a:rPr>
-              <a:t>AUC chosen because staff need a ranking of who to help first</a:t>
-            </a:r>
-            <a:endParaRPr lang="en-US" sz="1400" dirty="0"/>
+              <a:t> </a:t>
+            </a:r>
+            <a:endParaRPr lang="en-US" sz="1300" dirty="0"/>
+          </a:p>
+          <a:p>
+            <a:pPr indent="0" marL="0">
+              <a:buNone/>
+            </a:pPr>
+            <a:r>
+              <a:rPr lang="en-US" sz="1300" i="1" dirty="0">
+                <a:solidFill>
+                  <a:schemeClr val="tx1"/>
+                </a:solidFill>
+              </a:rPr>
+              <a:t>0 = covers nothing employers ask for, 1 = covers everything. Gaps are ranked by d(s).</a:t>
+            </a:r>
+            <a:endParaRPr lang="en-US" sz="1300" dirty="0"/>
           </a:p>
         </p:txBody>
       </p:sp>
       <p:graphicFrame>
         <p:nvGraphicFramePr>
-          <p:cNvPr id="4" name="Chart 0" descr=""/>
+          <p:cNvPr id="5" name="Chart 0" descr=""/>
           <p:cNvGraphicFramePr/>
           <p:nvPr/>
         </p:nvGraphicFramePr>
         <p:xfrm>
-          <a:off x="4297680" y="1051560"/>
-          <a:ext cx="4389120" cy="3474720"/>
+          <a:off x="4206240" y="1051560"/>
+          <a:ext cx="4480560" cy="3474720"/>
         </p:xfrm>
         <a:graphic xmlns:a="http://schemas.openxmlformats.org/drawingml/2006/main">
           <a:graphicData uri="http://schemas.openxmlformats.org/drawingml/2006/chart">
@@ -4533,7 +4851,7 @@
                   <a:schemeClr val="tx2"/>
                 </a:solidFill>
               </a:rPr>
-              <a:t>Results at a glance</a:t>
+              <a:t>Placement prediction model</a:t>
             </a:r>
             <a:endParaRPr lang="en-US" sz="2800" dirty="0"/>
           </a:p>
@@ -4541,402 +4859,14 @@
       </p:sp>
       <p:sp>
         <p:nvSpPr>
-          <p:cNvPr id="3" name="Shape 1"/>
-          <p:cNvSpPr/>
-          <p:nvPr/>
-        </p:nvSpPr>
-        <p:spPr>
-          <a:xfrm>
-            <a:off x="457200" y="1188720"/>
-            <a:ext cx="1920240" cy="2011680"/>
-          </a:xfrm>
-          <a:prstGeom prst="roundRect">
-            <a:avLst>
-              <a:gd name="adj" fmla="val 5714"/>
-            </a:avLst>
-          </a:prstGeom>
-          <a:solidFill>
-            <a:schemeClr val="bg2"/>
-          </a:solidFill>
-          <a:ln/>
-        </p:spPr>
-      </p:sp>
-      <p:sp>
-        <p:nvSpPr>
-          <p:cNvPr id="4" name="Text 2"/>
+          <p:cNvPr id="3" name="Text 1"/>
           <p:cNvSpPr txBox="1"/>
           <p:nvPr/>
         </p:nvSpPr>
         <p:spPr>
           <a:xfrm>
-            <a:off x="640080" y="1463040"/>
-            <a:ext cx="1645920" cy="777240"/>
-          </a:xfrm>
-          <a:prstGeom prst="rect">
-            <a:avLst/>
-          </a:prstGeom>
-          <a:noFill/>
-          <a:ln/>
-        </p:spPr>
-        <p:txBody>
-          <a:bodyPr wrap="square" lIns="0" tIns="0" rIns="0" bIns="0" rtlCol="0" anchor="ctr"/>
-          <a:lstStyle/>
-          <a:p>
-            <a:pPr indent="0" marL="0">
-              <a:buNone/>
-            </a:pPr>
-            <a:r>
-              <a:rPr lang="en-US" sz="3400" b="1" dirty="0">
-                <a:solidFill>
-                  <a:schemeClr val="accent2"/>
-                </a:solidFill>
-                <a:latin typeface="Cambria" pitchFamily="34" charset="0"/>
-                <a:ea typeface="Cambria" pitchFamily="34" charset="-122"/>
-                <a:cs typeface="Cambria" pitchFamily="34" charset="-120"/>
-              </a:rPr>
-              <a:t>0.947</a:t>
-            </a:r>
-            <a:endParaRPr lang="en-US" sz="3400" dirty="0"/>
-          </a:p>
-        </p:txBody>
-      </p:sp>
-      <p:sp>
-        <p:nvSpPr>
-          <p:cNvPr id="5" name="Text 3"/>
-          <p:cNvSpPr txBox="1"/>
-          <p:nvPr/>
-        </p:nvSpPr>
-        <p:spPr>
-          <a:xfrm>
-            <a:off x="640080" y="2240280"/>
-            <a:ext cx="1645920" cy="548640"/>
-          </a:xfrm>
-          <a:prstGeom prst="rect">
-            <a:avLst/>
-          </a:prstGeom>
-          <a:noFill/>
-          <a:ln/>
-        </p:spPr>
-        <p:txBody>
-          <a:bodyPr wrap="square" lIns="0" tIns="0" rIns="0" bIns="0" rtlCol="0" anchor="t"/>
-          <a:lstStyle/>
-          <a:p>
-            <a:pPr indent="0" marL="0">
-              <a:buNone/>
-            </a:pPr>
-            <a:r>
-              <a:rPr lang="en-US" sz="1300" dirty="0">
-                <a:solidFill>
-                  <a:schemeClr val="tx1"/>
-                </a:solidFill>
-              </a:rPr>
-              <a:t>ROC AUC on real data</a:t>
-            </a:r>
-            <a:endParaRPr lang="en-US" sz="1300" dirty="0"/>
-          </a:p>
-        </p:txBody>
-      </p:sp>
-      <p:sp>
-        <p:nvSpPr>
-          <p:cNvPr id="6" name="Shape 4"/>
-          <p:cNvSpPr/>
-          <p:nvPr/>
-        </p:nvSpPr>
-        <p:spPr>
-          <a:xfrm>
-            <a:off x="2560320" y="1188720"/>
-            <a:ext cx="1920240" cy="2011680"/>
-          </a:xfrm>
-          <a:prstGeom prst="roundRect">
-            <a:avLst>
-              <a:gd name="adj" fmla="val 5714"/>
-            </a:avLst>
-          </a:prstGeom>
-          <a:solidFill>
-            <a:schemeClr val="bg2"/>
-          </a:solidFill>
-          <a:ln/>
-        </p:spPr>
-      </p:sp>
-      <p:sp>
-        <p:nvSpPr>
-          <p:cNvPr id="7" name="Text 5"/>
-          <p:cNvSpPr txBox="1"/>
-          <p:nvPr/>
-        </p:nvSpPr>
-        <p:spPr>
-          <a:xfrm>
-            <a:off x="2743200" y="1463040"/>
-            <a:ext cx="1645920" cy="777240"/>
-          </a:xfrm>
-          <a:prstGeom prst="rect">
-            <a:avLst/>
-          </a:prstGeom>
-          <a:noFill/>
-          <a:ln/>
-        </p:spPr>
-        <p:txBody>
-          <a:bodyPr wrap="square" lIns="0" tIns="0" rIns="0" bIns="0" rtlCol="0" anchor="ctr"/>
-          <a:lstStyle/>
-          <a:p>
-            <a:pPr indent="0" marL="0">
-              <a:buNone/>
-            </a:pPr>
-            <a:r>
-              <a:rPr lang="en-US" sz="3400" b="1" dirty="0">
-                <a:solidFill>
-                  <a:schemeClr val="accent2"/>
-                </a:solidFill>
-                <a:latin typeface="Cambria" pitchFamily="34" charset="0"/>
-                <a:ea typeface="Cambria" pitchFamily="34" charset="-122"/>
-                <a:cs typeface="Cambria" pitchFamily="34" charset="-120"/>
-              </a:rPr>
-              <a:t>83.3%</a:t>
-            </a:r>
-            <a:endParaRPr lang="en-US" sz="3400" dirty="0"/>
-          </a:p>
-        </p:txBody>
-      </p:sp>
-      <p:sp>
-        <p:nvSpPr>
-          <p:cNvPr id="8" name="Text 6"/>
-          <p:cNvSpPr txBox="1"/>
-          <p:nvPr/>
-        </p:nvSpPr>
-        <p:spPr>
-          <a:xfrm>
-            <a:off x="2743200" y="2240280"/>
-            <a:ext cx="1645920" cy="548640"/>
-          </a:xfrm>
-          <a:prstGeom prst="rect">
-            <a:avLst/>
-          </a:prstGeom>
-          <a:noFill/>
-          <a:ln/>
-        </p:spPr>
-        <p:txBody>
-          <a:bodyPr wrap="square" lIns="0" tIns="0" rIns="0" bIns="0" rtlCol="0" anchor="t"/>
-          <a:lstStyle/>
-          <a:p>
-            <a:pPr indent="0" marL="0">
-              <a:buNone/>
-            </a:pPr>
-            <a:r>
-              <a:rPr lang="en-US" sz="1300" dirty="0">
-                <a:solidFill>
-                  <a:schemeClr val="tx1"/>
-                </a:solidFill>
-              </a:rPr>
-              <a:t>accuracy on real data</a:t>
-            </a:r>
-            <a:endParaRPr lang="en-US" sz="1300" dirty="0"/>
-          </a:p>
-        </p:txBody>
-      </p:sp>
-      <p:sp>
-        <p:nvSpPr>
-          <p:cNvPr id="9" name="Shape 7"/>
-          <p:cNvSpPr/>
-          <p:nvPr/>
-        </p:nvSpPr>
-        <p:spPr>
-          <a:xfrm>
-            <a:off x="4663440" y="1188720"/>
-            <a:ext cx="1920240" cy="2011680"/>
-          </a:xfrm>
-          <a:prstGeom prst="roundRect">
-            <a:avLst>
-              <a:gd name="adj" fmla="val 5714"/>
-            </a:avLst>
-          </a:prstGeom>
-          <a:solidFill>
-            <a:schemeClr val="bg2"/>
-          </a:solidFill>
-          <a:ln/>
-        </p:spPr>
-      </p:sp>
-      <p:sp>
-        <p:nvSpPr>
-          <p:cNvPr id="10" name="Text 8"/>
-          <p:cNvSpPr txBox="1"/>
-          <p:nvPr/>
-        </p:nvSpPr>
-        <p:spPr>
-          <a:xfrm>
-            <a:off x="4846320" y="1463040"/>
-            <a:ext cx="1645920" cy="777240"/>
-          </a:xfrm>
-          <a:prstGeom prst="rect">
-            <a:avLst/>
-          </a:prstGeom>
-          <a:noFill/>
-          <a:ln/>
-        </p:spPr>
-        <p:txBody>
-          <a:bodyPr wrap="square" lIns="0" tIns="0" rIns="0" bIns="0" rtlCol="0" anchor="ctr"/>
-          <a:lstStyle/>
-          <a:p>
-            <a:pPr indent="0" marL="0">
-              <a:buNone/>
-            </a:pPr>
-            <a:r>
-              <a:rPr lang="en-US" sz="3400" b="1" dirty="0">
-                <a:solidFill>
-                  <a:schemeClr val="accent1"/>
-                </a:solidFill>
-                <a:latin typeface="Cambria" pitchFamily="34" charset="0"/>
-                <a:ea typeface="Cambria" pitchFamily="34" charset="-122"/>
-                <a:cs typeface="Cambria" pitchFamily="34" charset="-120"/>
-              </a:rPr>
-              <a:t>99.2%</a:t>
-            </a:r>
-            <a:endParaRPr lang="en-US" sz="3400" dirty="0"/>
-          </a:p>
-        </p:txBody>
-      </p:sp>
-      <p:sp>
-        <p:nvSpPr>
-          <p:cNvPr id="11" name="Text 9"/>
-          <p:cNvSpPr txBox="1"/>
-          <p:nvPr/>
-        </p:nvSpPr>
-        <p:spPr>
-          <a:xfrm>
-            <a:off x="4846320" y="2240280"/>
-            <a:ext cx="1645920" cy="548640"/>
-          </a:xfrm>
-          <a:prstGeom prst="rect">
-            <a:avLst/>
-          </a:prstGeom>
-          <a:noFill/>
-          <a:ln/>
-        </p:spPr>
-        <p:txBody>
-          <a:bodyPr wrap="square" lIns="0" tIns="0" rIns="0" bIns="0" rtlCol="0" anchor="t"/>
-          <a:lstStyle/>
-          <a:p>
-            <a:pPr indent="0" marL="0">
-              <a:buNone/>
-            </a:pPr>
-            <a:r>
-              <a:rPr lang="en-US" sz="1300" dirty="0">
-                <a:solidFill>
-                  <a:schemeClr val="tx1"/>
-                </a:solidFill>
-              </a:rPr>
-              <a:t>skill-extraction precision</a:t>
-            </a:r>
-            <a:endParaRPr lang="en-US" sz="1300" dirty="0"/>
-          </a:p>
-        </p:txBody>
-      </p:sp>
-      <p:sp>
-        <p:nvSpPr>
-          <p:cNvPr id="12" name="Shape 10"/>
-          <p:cNvSpPr/>
-          <p:nvPr/>
-        </p:nvSpPr>
-        <p:spPr>
-          <a:xfrm>
-            <a:off x="6766560" y="1188720"/>
-            <a:ext cx="1920240" cy="2011680"/>
-          </a:xfrm>
-          <a:prstGeom prst="roundRect">
-            <a:avLst>
-              <a:gd name="adj" fmla="val 5714"/>
-            </a:avLst>
-          </a:prstGeom>
-          <a:solidFill>
-            <a:schemeClr val="bg2"/>
-          </a:solidFill>
-          <a:ln/>
-        </p:spPr>
-      </p:sp>
-      <p:sp>
-        <p:nvSpPr>
-          <p:cNvPr id="13" name="Text 11"/>
-          <p:cNvSpPr txBox="1"/>
-          <p:nvPr/>
-        </p:nvSpPr>
-        <p:spPr>
-          <a:xfrm>
-            <a:off x="6949440" y="1463040"/>
-            <a:ext cx="1645920" cy="777240"/>
-          </a:xfrm>
-          <a:prstGeom prst="rect">
-            <a:avLst/>
-          </a:prstGeom>
-          <a:noFill/>
-          <a:ln/>
-        </p:spPr>
-        <p:txBody>
-          <a:bodyPr wrap="square" lIns="0" tIns="0" rIns="0" bIns="0" rtlCol="0" anchor="ctr"/>
-          <a:lstStyle/>
-          <a:p>
-            <a:pPr indent="0" marL="0">
-              <a:buNone/>
-            </a:pPr>
-            <a:r>
-              <a:rPr lang="en-US" sz="3400" b="1" dirty="0">
-                <a:solidFill>
-                  <a:schemeClr val="accent5"/>
-                </a:solidFill>
-                <a:latin typeface="Cambria" pitchFamily="34" charset="0"/>
-                <a:ea typeface="Cambria" pitchFamily="34" charset="-122"/>
-                <a:cs typeface="Cambria" pitchFamily="34" charset="-120"/>
-              </a:rPr>
-              <a:t>1,500</a:t>
-            </a:r>
-            <a:endParaRPr lang="en-US" sz="3400" dirty="0"/>
-          </a:p>
-        </p:txBody>
-      </p:sp>
-      <p:sp>
-        <p:nvSpPr>
-          <p:cNvPr id="14" name="Text 12"/>
-          <p:cNvSpPr txBox="1"/>
-          <p:nvPr/>
-        </p:nvSpPr>
-        <p:spPr>
-          <a:xfrm>
-            <a:off x="6949440" y="2240280"/>
-            <a:ext cx="1645920" cy="548640"/>
-          </a:xfrm>
-          <a:prstGeom prst="rect">
-            <a:avLst/>
-          </a:prstGeom>
-          <a:noFill/>
-          <a:ln/>
-        </p:spPr>
-        <p:txBody>
-          <a:bodyPr wrap="square" lIns="0" tIns="0" rIns="0" bIns="0" rtlCol="0" anchor="t"/>
-          <a:lstStyle/>
-          <a:p>
-            <a:pPr indent="0" marL="0">
-              <a:buNone/>
-            </a:pPr>
-            <a:r>
-              <a:rPr lang="en-US" sz="1300" dirty="0">
-                <a:solidFill>
-                  <a:schemeClr val="tx1"/>
-                </a:solidFill>
-              </a:rPr>
-              <a:t>real postings indexed and searchable</a:t>
-            </a:r>
-            <a:endParaRPr lang="en-US" sz="1300" dirty="0"/>
-          </a:p>
-        </p:txBody>
-      </p:sp>
-      <p:sp>
-        <p:nvSpPr>
-          <p:cNvPr id="15" name="Text 13"/>
-          <p:cNvSpPr txBox="1"/>
-          <p:nvPr/>
-        </p:nvSpPr>
-        <p:spPr>
-          <a:xfrm>
-            <a:off x="457200" y="3474720"/>
-            <a:ext cx="8229600" cy="1005840"/>
+            <a:off x="457200" y="1143000"/>
+            <a:ext cx="3657600" cy="3291840"/>
           </a:xfrm>
           <a:prstGeom prst="rect">
             <a:avLst/>
@@ -4961,7 +4891,7 @@
                   <a:schemeClr val="tx1"/>
                 </a:solidFill>
               </a:rPr>
-              <a:t>Logistic regression selected; CGPA is the strongest predictor (coefficient 2.24), then internships (0.69)</a:t>
+              <a:t>6 features: CGPA, projects, certifications, internships, skill count, alignment score</a:t>
             </a:r>
             <a:endParaRPr lang="en-US" sz="1400" dirty="0"/>
           </a:p>
@@ -4979,12 +4909,64 @@
                   <a:schemeClr val="tx1"/>
                 </a:solidFill>
               </a:rPr>
-              <a:t>Airflow DAG: all 4 tasks succeed in ~33 s  ·  Kafka: 10/10 streamed postings processed live</a:t>
+              <a:t>Standardised; 75/25 stratified split, fixed seed</a:t>
             </a:r>
             <a:endParaRPr lang="en-US" sz="1400" dirty="0"/>
           </a:p>
-        </p:txBody>
-      </p:sp>
+          <a:p>
+            <a:pPr marL="342900" indent="-342900">
+              <a:spcAft>
+                <a:spcPts val="800"/>
+              </a:spcAft>
+              <a:buSzPct val="100000"/>
+              <a:buChar char="•"/>
+            </a:pPr>
+            <a:r>
+              <a:rPr lang="en-US" sz="1400" dirty="0">
+                <a:solidFill>
+                  <a:schemeClr val="tx1"/>
+                </a:solidFill>
+              </a:rPr>
+              <a:t>Logistic regression vs XGBoost — higher held-out ROC AUC is kept</a:t>
+            </a:r>
+            <a:endParaRPr lang="en-US" sz="1400" dirty="0"/>
+          </a:p>
+          <a:p>
+            <a:pPr marL="342900" indent="-342900">
+              <a:spcAft>
+                <a:spcPts val="800"/>
+              </a:spcAft>
+              <a:buSzPct val="100000"/>
+              <a:buChar char="•"/>
+            </a:pPr>
+            <a:r>
+              <a:rPr lang="en-US" sz="1400" dirty="0">
+                <a:solidFill>
+                  <a:schemeClr val="tx1"/>
+                </a:solidFill>
+              </a:rPr>
+              <a:t>AUC chosen because staff need a ranking of who to help first</a:t>
+            </a:r>
+            <a:endParaRPr lang="en-US" sz="1400" dirty="0"/>
+          </a:p>
+        </p:txBody>
+      </p:sp>
+      <p:graphicFrame>
+        <p:nvGraphicFramePr>
+          <p:cNvPr id="4" name="Chart 0" descr=""/>
+          <p:cNvGraphicFramePr/>
+          <p:nvPr/>
+        </p:nvGraphicFramePr>
+        <p:xfrm>
+          <a:off x="4297680" y="1051560"/>
+          <a:ext cx="4389120" cy="3474720"/>
+        </p:xfrm>
+        <a:graphic xmlns:a="http://schemas.openxmlformats.org/drawingml/2006/main">
+          <a:graphicData uri="http://schemas.openxmlformats.org/drawingml/2006/chart">
+            <c:chart xmlns:c="http://schemas.openxmlformats.org/drawingml/2006/chart" r:id="rId1"/>
+          </a:graphicData>
+        </a:graphic>
+      </p:graphicFrame>
       <p:sp>
         <p:nvSpPr>
           <p:cNvPr id="25" name="Slide Number Placeholder 0"/>
@@ -5087,42 +5069,26 @@
                   <a:schemeClr val="tx2"/>
                 </a:solidFill>
               </a:rPr>
-              <a:t>What drives placement in this data</a:t>
+              <a:t>Results at a glance</a:t>
             </a:r>
             <a:endParaRPr lang="en-US" sz="2800" dirty="0"/>
           </a:p>
         </p:txBody>
       </p:sp>
-      <p:graphicFrame>
-        <p:nvGraphicFramePr>
-          <p:cNvPr id="3" name="Chart 0" descr=""/>
-          <p:cNvGraphicFramePr/>
-          <p:nvPr/>
-        </p:nvGraphicFramePr>
-        <p:xfrm>
-          <a:off x="457200" y="1051560"/>
-          <a:ext cx="4937760" cy="3474720"/>
-        </p:xfrm>
-        <a:graphic xmlns:a="http://schemas.openxmlformats.org/drawingml/2006/main">
-          <a:graphicData uri="http://schemas.openxmlformats.org/drawingml/2006/chart">
-            <c:chart xmlns:c="http://schemas.openxmlformats.org/drawingml/2006/chart" r:id="rId1"/>
-          </a:graphicData>
-        </a:graphic>
-      </p:graphicFrame>
-      <p:sp>
-        <p:nvSpPr>
-          <p:cNvPr id="4" name="Shape 1"/>
+      <p:sp>
+        <p:nvSpPr>
+          <p:cNvPr id="3" name="Shape 1"/>
           <p:cNvSpPr/>
           <p:nvPr/>
         </p:nvSpPr>
         <p:spPr>
           <a:xfrm>
-            <a:off x="5669280" y="1143000"/>
-            <a:ext cx="3017520" cy="3337560"/>
+            <a:off x="457200" y="1188720"/>
+            <a:ext cx="1920240" cy="2011680"/>
           </a:xfrm>
           <a:prstGeom prst="roundRect">
             <a:avLst>
-              <a:gd name="adj" fmla="val 3636"/>
+              <a:gd name="adj" fmla="val 5714"/>
             </a:avLst>
           </a:prstGeom>
           <a:solidFill>
@@ -5133,14 +5099,14 @@
       </p:sp>
       <p:sp>
         <p:nvSpPr>
-          <p:cNvPr id="5" name="Text 2"/>
+          <p:cNvPr id="4" name="Text 2"/>
           <p:cNvSpPr txBox="1"/>
           <p:nvPr/>
         </p:nvSpPr>
         <p:spPr>
           <a:xfrm>
-            <a:off x="5897880" y="1280160"/>
-            <a:ext cx="2651760" cy="411480"/>
+            <a:off x="640080" y="1463040"/>
+            <a:ext cx="1645920" cy="777240"/>
           </a:xfrm>
           <a:prstGeom prst="rect">
             <a:avLst/>
@@ -5156,27 +5122,357 @@
               <a:buNone/>
             </a:pPr>
             <a:r>
-              <a:rPr lang="en-US" sz="1600" b="1" dirty="0">
-                <a:solidFill>
-                  <a:schemeClr val="accent4"/>
-                </a:solidFill>
-              </a:rPr>
-              <a:t>Honest reading</a:t>
-            </a:r>
-            <a:endParaRPr lang="en-US" sz="1600" dirty="0"/>
-          </a:p>
-        </p:txBody>
-      </p:sp>
-      <p:sp>
-        <p:nvSpPr>
-          <p:cNvPr id="6" name="Text 3"/>
+              <a:rPr lang="en-US" sz="3400" b="1" dirty="0">
+                <a:solidFill>
+                  <a:schemeClr val="accent2"/>
+                </a:solidFill>
+                <a:latin typeface="Cambria" pitchFamily="34" charset="0"/>
+                <a:ea typeface="Cambria" pitchFamily="34" charset="-122"/>
+                <a:cs typeface="Cambria" pitchFamily="34" charset="-120"/>
+              </a:rPr>
+              <a:t>0.947</a:t>
+            </a:r>
+            <a:endParaRPr lang="en-US" sz="3400" dirty="0"/>
+          </a:p>
+        </p:txBody>
+      </p:sp>
+      <p:sp>
+        <p:nvSpPr>
+          <p:cNvPr id="5" name="Text 3"/>
           <p:cNvSpPr txBox="1"/>
           <p:nvPr/>
         </p:nvSpPr>
         <p:spPr>
           <a:xfrm>
-            <a:off x="5897880" y="1737360"/>
-            <a:ext cx="2651760" cy="2651760"/>
+            <a:off x="640080" y="2240280"/>
+            <a:ext cx="1645920" cy="548640"/>
+          </a:xfrm>
+          <a:prstGeom prst="rect">
+            <a:avLst/>
+          </a:prstGeom>
+          <a:noFill/>
+          <a:ln/>
+        </p:spPr>
+        <p:txBody>
+          <a:bodyPr wrap="square" lIns="0" tIns="0" rIns="0" bIns="0" rtlCol="0" anchor="t"/>
+          <a:lstStyle/>
+          <a:p>
+            <a:pPr indent="0" marL="0">
+              <a:buNone/>
+            </a:pPr>
+            <a:r>
+              <a:rPr lang="en-US" sz="1300" dirty="0">
+                <a:solidFill>
+                  <a:schemeClr val="tx1"/>
+                </a:solidFill>
+              </a:rPr>
+              <a:t>ROC AUC on real data</a:t>
+            </a:r>
+            <a:endParaRPr lang="en-US" sz="1300" dirty="0"/>
+          </a:p>
+        </p:txBody>
+      </p:sp>
+      <p:sp>
+        <p:nvSpPr>
+          <p:cNvPr id="6" name="Shape 4"/>
+          <p:cNvSpPr/>
+          <p:nvPr/>
+        </p:nvSpPr>
+        <p:spPr>
+          <a:xfrm>
+            <a:off x="2560320" y="1188720"/>
+            <a:ext cx="1920240" cy="2011680"/>
+          </a:xfrm>
+          <a:prstGeom prst="roundRect">
+            <a:avLst>
+              <a:gd name="adj" fmla="val 5714"/>
+            </a:avLst>
+          </a:prstGeom>
+          <a:solidFill>
+            <a:schemeClr val="bg2"/>
+          </a:solidFill>
+          <a:ln/>
+        </p:spPr>
+      </p:sp>
+      <p:sp>
+        <p:nvSpPr>
+          <p:cNvPr id="7" name="Text 5"/>
+          <p:cNvSpPr txBox="1"/>
+          <p:nvPr/>
+        </p:nvSpPr>
+        <p:spPr>
+          <a:xfrm>
+            <a:off x="2743200" y="1463040"/>
+            <a:ext cx="1645920" cy="777240"/>
+          </a:xfrm>
+          <a:prstGeom prst="rect">
+            <a:avLst/>
+          </a:prstGeom>
+          <a:noFill/>
+          <a:ln/>
+        </p:spPr>
+        <p:txBody>
+          <a:bodyPr wrap="square" lIns="0" tIns="0" rIns="0" bIns="0" rtlCol="0" anchor="ctr"/>
+          <a:lstStyle/>
+          <a:p>
+            <a:pPr indent="0" marL="0">
+              <a:buNone/>
+            </a:pPr>
+            <a:r>
+              <a:rPr lang="en-US" sz="3400" b="1" dirty="0">
+                <a:solidFill>
+                  <a:schemeClr val="accent2"/>
+                </a:solidFill>
+                <a:latin typeface="Cambria" pitchFamily="34" charset="0"/>
+                <a:ea typeface="Cambria" pitchFamily="34" charset="-122"/>
+                <a:cs typeface="Cambria" pitchFamily="34" charset="-120"/>
+              </a:rPr>
+              <a:t>83.3%</a:t>
+            </a:r>
+            <a:endParaRPr lang="en-US" sz="3400" dirty="0"/>
+          </a:p>
+        </p:txBody>
+      </p:sp>
+      <p:sp>
+        <p:nvSpPr>
+          <p:cNvPr id="8" name="Text 6"/>
+          <p:cNvSpPr txBox="1"/>
+          <p:nvPr/>
+        </p:nvSpPr>
+        <p:spPr>
+          <a:xfrm>
+            <a:off x="2743200" y="2240280"/>
+            <a:ext cx="1645920" cy="548640"/>
+          </a:xfrm>
+          <a:prstGeom prst="rect">
+            <a:avLst/>
+          </a:prstGeom>
+          <a:noFill/>
+          <a:ln/>
+        </p:spPr>
+        <p:txBody>
+          <a:bodyPr wrap="square" lIns="0" tIns="0" rIns="0" bIns="0" rtlCol="0" anchor="t"/>
+          <a:lstStyle/>
+          <a:p>
+            <a:pPr indent="0" marL="0">
+              <a:buNone/>
+            </a:pPr>
+            <a:r>
+              <a:rPr lang="en-US" sz="1300" dirty="0">
+                <a:solidFill>
+                  <a:schemeClr val="tx1"/>
+                </a:solidFill>
+              </a:rPr>
+              <a:t>accuracy on real data</a:t>
+            </a:r>
+            <a:endParaRPr lang="en-US" sz="1300" dirty="0"/>
+          </a:p>
+        </p:txBody>
+      </p:sp>
+      <p:sp>
+        <p:nvSpPr>
+          <p:cNvPr id="9" name="Shape 7"/>
+          <p:cNvSpPr/>
+          <p:nvPr/>
+        </p:nvSpPr>
+        <p:spPr>
+          <a:xfrm>
+            <a:off x="4663440" y="1188720"/>
+            <a:ext cx="1920240" cy="2011680"/>
+          </a:xfrm>
+          <a:prstGeom prst="roundRect">
+            <a:avLst>
+              <a:gd name="adj" fmla="val 5714"/>
+            </a:avLst>
+          </a:prstGeom>
+          <a:solidFill>
+            <a:schemeClr val="bg2"/>
+          </a:solidFill>
+          <a:ln/>
+        </p:spPr>
+      </p:sp>
+      <p:sp>
+        <p:nvSpPr>
+          <p:cNvPr id="10" name="Text 8"/>
+          <p:cNvSpPr txBox="1"/>
+          <p:nvPr/>
+        </p:nvSpPr>
+        <p:spPr>
+          <a:xfrm>
+            <a:off x="4846320" y="1463040"/>
+            <a:ext cx="1645920" cy="777240"/>
+          </a:xfrm>
+          <a:prstGeom prst="rect">
+            <a:avLst/>
+          </a:prstGeom>
+          <a:noFill/>
+          <a:ln/>
+        </p:spPr>
+        <p:txBody>
+          <a:bodyPr wrap="square" lIns="0" tIns="0" rIns="0" bIns="0" rtlCol="0" anchor="ctr"/>
+          <a:lstStyle/>
+          <a:p>
+            <a:pPr indent="0" marL="0">
+              <a:buNone/>
+            </a:pPr>
+            <a:r>
+              <a:rPr lang="en-US" sz="3400" b="1" dirty="0">
+                <a:solidFill>
+                  <a:schemeClr val="accent1"/>
+                </a:solidFill>
+                <a:latin typeface="Cambria" pitchFamily="34" charset="0"/>
+                <a:ea typeface="Cambria" pitchFamily="34" charset="-122"/>
+                <a:cs typeface="Cambria" pitchFamily="34" charset="-120"/>
+              </a:rPr>
+              <a:t>99.2%</a:t>
+            </a:r>
+            <a:endParaRPr lang="en-US" sz="3400" dirty="0"/>
+          </a:p>
+        </p:txBody>
+      </p:sp>
+      <p:sp>
+        <p:nvSpPr>
+          <p:cNvPr id="11" name="Text 9"/>
+          <p:cNvSpPr txBox="1"/>
+          <p:nvPr/>
+        </p:nvSpPr>
+        <p:spPr>
+          <a:xfrm>
+            <a:off x="4846320" y="2240280"/>
+            <a:ext cx="1645920" cy="548640"/>
+          </a:xfrm>
+          <a:prstGeom prst="rect">
+            <a:avLst/>
+          </a:prstGeom>
+          <a:noFill/>
+          <a:ln/>
+        </p:spPr>
+        <p:txBody>
+          <a:bodyPr wrap="square" lIns="0" tIns="0" rIns="0" bIns="0" rtlCol="0" anchor="t"/>
+          <a:lstStyle/>
+          <a:p>
+            <a:pPr indent="0" marL="0">
+              <a:buNone/>
+            </a:pPr>
+            <a:r>
+              <a:rPr lang="en-US" sz="1300" dirty="0">
+                <a:solidFill>
+                  <a:schemeClr val="tx1"/>
+                </a:solidFill>
+              </a:rPr>
+              <a:t>skill-extraction precision</a:t>
+            </a:r>
+            <a:endParaRPr lang="en-US" sz="1300" dirty="0"/>
+          </a:p>
+        </p:txBody>
+      </p:sp>
+      <p:sp>
+        <p:nvSpPr>
+          <p:cNvPr id="12" name="Shape 10"/>
+          <p:cNvSpPr/>
+          <p:nvPr/>
+        </p:nvSpPr>
+        <p:spPr>
+          <a:xfrm>
+            <a:off x="6766560" y="1188720"/>
+            <a:ext cx="1920240" cy="2011680"/>
+          </a:xfrm>
+          <a:prstGeom prst="roundRect">
+            <a:avLst>
+              <a:gd name="adj" fmla="val 5714"/>
+            </a:avLst>
+          </a:prstGeom>
+          <a:solidFill>
+            <a:schemeClr val="bg2"/>
+          </a:solidFill>
+          <a:ln/>
+        </p:spPr>
+      </p:sp>
+      <p:sp>
+        <p:nvSpPr>
+          <p:cNvPr id="13" name="Text 11"/>
+          <p:cNvSpPr txBox="1"/>
+          <p:nvPr/>
+        </p:nvSpPr>
+        <p:spPr>
+          <a:xfrm>
+            <a:off x="6949440" y="1463040"/>
+            <a:ext cx="1645920" cy="777240"/>
+          </a:xfrm>
+          <a:prstGeom prst="rect">
+            <a:avLst/>
+          </a:prstGeom>
+          <a:noFill/>
+          <a:ln/>
+        </p:spPr>
+        <p:txBody>
+          <a:bodyPr wrap="square" lIns="0" tIns="0" rIns="0" bIns="0" rtlCol="0" anchor="ctr"/>
+          <a:lstStyle/>
+          <a:p>
+            <a:pPr indent="0" marL="0">
+              <a:buNone/>
+            </a:pPr>
+            <a:r>
+              <a:rPr lang="en-US" sz="3400" b="1" dirty="0">
+                <a:solidFill>
+                  <a:schemeClr val="accent5"/>
+                </a:solidFill>
+                <a:latin typeface="Cambria" pitchFamily="34" charset="0"/>
+                <a:ea typeface="Cambria" pitchFamily="34" charset="-122"/>
+                <a:cs typeface="Cambria" pitchFamily="34" charset="-120"/>
+              </a:rPr>
+              <a:t>1,500</a:t>
+            </a:r>
+            <a:endParaRPr lang="en-US" sz="3400" dirty="0"/>
+          </a:p>
+        </p:txBody>
+      </p:sp>
+      <p:sp>
+        <p:nvSpPr>
+          <p:cNvPr id="14" name="Text 12"/>
+          <p:cNvSpPr txBox="1"/>
+          <p:nvPr/>
+        </p:nvSpPr>
+        <p:spPr>
+          <a:xfrm>
+            <a:off x="6949440" y="2240280"/>
+            <a:ext cx="1645920" cy="548640"/>
+          </a:xfrm>
+          <a:prstGeom prst="rect">
+            <a:avLst/>
+          </a:prstGeom>
+          <a:noFill/>
+          <a:ln/>
+        </p:spPr>
+        <p:txBody>
+          <a:bodyPr wrap="square" lIns="0" tIns="0" rIns="0" bIns="0" rtlCol="0" anchor="t"/>
+          <a:lstStyle/>
+          <a:p>
+            <a:pPr indent="0" marL="0">
+              <a:buNone/>
+            </a:pPr>
+            <a:r>
+              <a:rPr lang="en-US" sz="1300" dirty="0">
+                <a:solidFill>
+                  <a:schemeClr val="tx1"/>
+                </a:solidFill>
+              </a:rPr>
+              <a:t>real postings indexed and searchable</a:t>
+            </a:r>
+            <a:endParaRPr lang="en-US" sz="1300" dirty="0"/>
+          </a:p>
+        </p:txBody>
+      </p:sp>
+      <p:sp>
+        <p:nvSpPr>
+          <p:cNvPr id="15" name="Text 13"/>
+          <p:cNvSpPr txBox="1"/>
+          <p:nvPr/>
+        </p:nvSpPr>
+        <p:spPr>
+          <a:xfrm>
+            <a:off x="457200" y="3474720"/>
+            <a:ext cx="8229600" cy="1005840"/>
           </a:xfrm>
           <a:prstGeom prst="rect">
             <a:avLst/>
@@ -5196,14 +5492,14 @@
               <a:buChar char="•"/>
             </a:pPr>
             <a:r>
-              <a:rPr lang="en-US" sz="1300" dirty="0">
+              <a:rPr lang="en-US" sz="1400" dirty="0">
                 <a:solidFill>
                   <a:schemeClr val="tx1"/>
                 </a:solidFill>
               </a:rPr>
-              <a:t>Academics dominate — expected for this dataset</a:t>
-            </a:r>
-            <a:endParaRPr lang="en-US" sz="1300" dirty="0"/>
+              <a:t>Logistic regression selected; CGPA is the strongest predictor (coefficient 2.24), then internships (0.69)</a:t>
+            </a:r>
+            <a:endParaRPr lang="en-US" sz="1400" dirty="0"/>
           </a:p>
           <a:p>
             <a:pPr marL="342900" indent="-342900">
@@ -5214,32 +5510,14 @@
               <a:buChar char="•"/>
             </a:pPr>
             <a:r>
-              <a:rPr lang="en-US" sz="1300" dirty="0">
+              <a:rPr lang="en-US" sz="1400" dirty="0">
                 <a:solidFill>
                   <a:schemeClr val="tx1"/>
                 </a:solidFill>
               </a:rPr>
-              <a:t>Projects and certifications are 0: not recorded in the source</a:t>
-            </a:r>
-            <a:endParaRPr lang="en-US" sz="1300" dirty="0"/>
-          </a:p>
-          <a:p>
-            <a:pPr marL="342900" indent="-342900">
-              <a:spcAft>
-                <a:spcPts val="800"/>
-              </a:spcAft>
-              <a:buSzPct val="100000"/>
-              <a:buChar char="•"/>
-            </a:pPr>
-            <a:r>
-              <a:rPr lang="en-US" sz="1300" dirty="0">
-                <a:solidFill>
-                  <a:schemeClr val="tx1"/>
-                </a:solidFill>
-              </a:rPr>
-              <a:t>Skill features are weak because skills were imputed, so the high AUC is not evidence that skills predict placement</a:t>
-            </a:r>
-            <a:endParaRPr lang="en-US" sz="1300" dirty="0"/>
+              <a:t>Airflow DAG: all 4 tasks succeed in ~33 s  ·  Kafka: 10/10 streamed postings processed live</a:t>
+            </a:r>
+            <a:endParaRPr lang="en-US" sz="1400" dirty="0"/>
           </a:p>
         </p:txBody>
       </p:sp>
@@ -5345,58 +5623,50 @@
                   <a:schemeClr val="tx2"/>
                 </a:solidFill>
               </a:rPr>
-              <a:t>Dashboard — Student 360</a:t>
+              <a:t>What drives placement in this data</a:t>
             </a:r>
             <a:endParaRPr lang="en-US" sz="2800" dirty="0"/>
           </a:p>
         </p:txBody>
       </p:sp>
-      <p:sp>
-        <p:nvSpPr>
-          <p:cNvPr id="3" name="Shape 1"/>
+      <p:graphicFrame>
+        <p:nvGraphicFramePr>
+          <p:cNvPr id="3" name="Chart 0" descr=""/>
+          <p:cNvGraphicFramePr/>
+          <p:nvPr/>
+        </p:nvGraphicFramePr>
+        <p:xfrm>
+          <a:off x="457200" y="1051560"/>
+          <a:ext cx="4937760" cy="3474720"/>
+        </p:xfrm>
+        <a:graphic xmlns:a="http://schemas.openxmlformats.org/drawingml/2006/main">
+          <a:graphicData uri="http://schemas.openxmlformats.org/drawingml/2006/chart">
+            <c:chart xmlns:c="http://schemas.openxmlformats.org/drawingml/2006/chart" r:id="rId1"/>
+          </a:graphicData>
+        </a:graphic>
+      </p:graphicFrame>
+      <p:sp>
+        <p:nvSpPr>
+          <p:cNvPr id="4" name="Shape 1"/>
           <p:cNvSpPr/>
           <p:nvPr/>
         </p:nvSpPr>
         <p:spPr>
           <a:xfrm>
-            <a:off x="411480" y="1005840"/>
-            <a:ext cx="5577840" cy="3529584"/>
+            <a:off x="5669280" y="1143000"/>
+            <a:ext cx="3017520" cy="3337560"/>
           </a:xfrm>
           <a:prstGeom prst="roundRect">
             <a:avLst>
-              <a:gd name="adj" fmla="val 1554"/>
+              <a:gd name="adj" fmla="val 3636"/>
             </a:avLst>
           </a:prstGeom>
           <a:solidFill>
-            <a:schemeClr val="tx2"/>
+            <a:schemeClr val="bg2"/>
           </a:solidFill>
           <a:ln/>
         </p:spPr>
       </p:sp>
-      <p:pic>
-        <p:nvPicPr>
-          <p:cNvPr id="4" name="Image 0" descr="Dashboard — Student 360">    </p:cNvPr>
-          <p:cNvPicPr>
-            <a:picLocks noChangeAspect="1"/>
-          </p:cNvPicPr>
-          <p:nvPr/>
-        </p:nvPicPr>
-        <p:blipFill>
-          <a:blip r:embed="rId1"/>
-          <a:stretch>
-            <a:fillRect/>
-          </a:stretch>
-        </p:blipFill>
-        <p:spPr>
-          <a:xfrm>
-            <a:off x="457200" y="1051560"/>
-            <a:ext cx="5486400" cy="3429000"/>
-          </a:xfrm>
-          <a:prstGeom prst="rect">
-            <a:avLst/>
-          </a:prstGeom>
-        </p:spPr>
-      </p:pic>
       <p:sp>
         <p:nvSpPr>
           <p:cNvPr id="5" name="Text 2"/>
@@ -5405,8 +5675,8 @@
         </p:nvSpPr>
         <p:spPr>
           <a:xfrm>
-            <a:off x="6217920" y="1051560"/>
-            <a:ext cx="2468880" cy="457200"/>
+            <a:off x="5897880" y="1280160"/>
+            <a:ext cx="2651760" cy="411480"/>
           </a:xfrm>
           <a:prstGeom prst="rect">
             <a:avLst/>
@@ -5424,10 +5694,10 @@
             <a:r>
               <a:rPr lang="en-US" sz="1600" b="1" dirty="0">
                 <a:solidFill>
-                  <a:schemeClr val="accent1"/>
-                </a:solidFill>
-              </a:rPr>
-              <a:t>One student, one page</a:t>
+                  <a:schemeClr val="accent4"/>
+                </a:solidFill>
+              </a:rPr>
+              <a:t>Honest reading</a:t>
             </a:r>
             <a:endParaRPr lang="en-US" sz="1600" dirty="0"/>
           </a:p>
@@ -5441,8 +5711,8 @@
         </p:nvSpPr>
         <p:spPr>
           <a:xfrm>
-            <a:off x="6217920" y="1554480"/>
-            <a:ext cx="2468880" cy="2377440"/>
+            <a:off x="5897880" y="1737360"/>
+            <a:ext cx="2651760" cy="2651760"/>
           </a:xfrm>
           <a:prstGeom prst="rect">
             <a:avLst/>
@@ -5467,7 +5737,7 @@
                   <a:schemeClr val="tx1"/>
                 </a:solidFill>
               </a:rPr>
-              <a:t>Placement probability gauge with risk tier</a:t>
+              <a:t>Academics dominate — expected for this dataset</a:t>
             </a:r>
             <a:endParaRPr lang="en-US" sz="1300" dirty="0"/>
           </a:p>
@@ -5485,7 +5755,7 @@
                   <a:schemeClr val="tx1"/>
                 </a:solidFill>
               </a:rPr>
-              <a:t>KPIs compared with the cohort median</a:t>
+              <a:t>Projects and certifications are 0: not recorded in the source</a:t>
             </a:r>
             <a:endParaRPr lang="en-US" sz="1300" dirty="0"/>
           </a:p>
@@ -5503,25 +5773,7 @@
                   <a:schemeClr val="tx1"/>
                 </a:solidFill>
               </a:rPr>
-              <a:t>Skill-coverage radar vs cohort average</a:t>
-            </a:r>
-            <a:endParaRPr lang="en-US" sz="1300" dirty="0"/>
-          </a:p>
-          <a:p>
-            <a:pPr marL="342900" indent="-342900">
-              <a:spcAft>
-                <a:spcPts val="800"/>
-              </a:spcAft>
-              <a:buSzPct val="100000"/>
-              <a:buChar char="•"/>
-            </a:pPr>
-            <a:r>
-              <a:rPr lang="en-US" sz="1300" dirty="0">
-                <a:solidFill>
-                  <a:schemeClr val="tx1"/>
-                </a:solidFill>
-              </a:rPr>
-              <a:t>Gaps ranked by market demand</a:t>
+              <a:t>Skill features are weak because skills were imputed, so the high AUC is not evidence that skills predict placement</a:t>
             </a:r>
             <a:endParaRPr lang="en-US" sz="1300" dirty="0"/>
           </a:p>
@@ -5629,37 +5881,15 @@
                   <a:schemeClr val="tx2"/>
                 </a:solidFill>
               </a:rPr>
-              <a:t>Dashboard — What-if simulator</a:t>
+              <a:t>Scenario: helping student S0001</a:t>
             </a:r>
             <a:endParaRPr lang="en-US" sz="2800" dirty="0"/>
           </a:p>
         </p:txBody>
-      </p:sp>
-      <p:sp>
-        <p:nvSpPr>
-          <p:cNvPr id="3" name="Shape 1"/>
-          <p:cNvSpPr/>
-          <p:nvPr/>
-        </p:nvSpPr>
-        <p:spPr>
-          <a:xfrm>
-            <a:off x="411480" y="1005840"/>
-            <a:ext cx="5577840" cy="3529584"/>
-          </a:xfrm>
-          <a:prstGeom prst="roundRect">
-            <a:avLst>
-              <a:gd name="adj" fmla="val 1554"/>
-            </a:avLst>
-          </a:prstGeom>
-          <a:solidFill>
-            <a:schemeClr val="tx2"/>
-          </a:solidFill>
-          <a:ln/>
-        </p:spPr>
       </p:sp>
       <p:pic>
         <p:nvPicPr>
-          <p:cNvPr id="4" name="Image 0" descr="Dashboard — What-if simulator">    </p:cNvPr>
+          <p:cNvPr id="3" name="Image 0" descr="Scenario: helping student S0001">    </p:cNvPr>
           <p:cNvPicPr>
             <a:picLocks noChangeAspect="1"/>
           </p:cNvPicPr>
@@ -5673,8 +5903,8 @@
         </p:blipFill>
         <p:spPr>
           <a:xfrm>
-            <a:off x="457200" y="1051560"/>
-            <a:ext cx="5486400" cy="3429000"/>
+            <a:off x="444504" y="914400"/>
+            <a:ext cx="8254993" cy="3520440"/>
           </a:xfrm>
           <a:prstGeom prst="rect">
             <a:avLst/>
@@ -5683,14 +5913,14 @@
       </p:pic>
       <p:sp>
         <p:nvSpPr>
-          <p:cNvPr id="5" name="Text 2"/>
+          <p:cNvPr id="4" name="Text 1"/>
           <p:cNvSpPr txBox="1"/>
           <p:nvPr/>
         </p:nvSpPr>
         <p:spPr>
           <a:xfrm>
-            <a:off x="6217920" y="1051560"/>
-            <a:ext cx="2468880" cy="457200"/>
+            <a:off x="457200" y="4407408"/>
+            <a:ext cx="8229600" cy="320040"/>
           </a:xfrm>
           <a:prstGeom prst="rect">
             <a:avLst/>
@@ -5702,130 +5932,18 @@
           <a:bodyPr wrap="square" lIns="0" tIns="0" rIns="0" bIns="0" rtlCol="0" anchor="ctr"/>
           <a:lstStyle/>
           <a:p>
-            <a:pPr indent="0" marL="0">
+            <a:pPr algn="ctr" indent="0" marL="0">
               <a:buNone/>
             </a:pPr>
             <a:r>
-              <a:rPr lang="en-US" sz="1600" b="1" dirty="0">
-                <a:solidFill>
-                  <a:schemeClr val="accent1"/>
-                </a:solidFill>
-              </a:rPr>
-              <a:t>Try a change, see the effect</a:t>
-            </a:r>
-            <a:endParaRPr lang="en-US" sz="1600" dirty="0"/>
-          </a:p>
-        </p:txBody>
-      </p:sp>
-      <p:sp>
-        <p:nvSpPr>
-          <p:cNvPr id="6" name="Text 3"/>
-          <p:cNvSpPr txBox="1"/>
-          <p:nvPr/>
-        </p:nvSpPr>
-        <p:spPr>
-          <a:xfrm>
-            <a:off x="6217920" y="1554480"/>
-            <a:ext cx="2468880" cy="2377440"/>
-          </a:xfrm>
-          <a:prstGeom prst="rect">
-            <a:avLst/>
-          </a:prstGeom>
-          <a:noFill/>
-          <a:ln/>
-        </p:spPr>
-        <p:txBody>
-          <a:bodyPr wrap="square" lIns="0" tIns="0" rIns="0" bIns="0" rtlCol="0" anchor="t"/>
-          <a:lstStyle/>
-          <a:p>
-            <a:pPr marL="342900" indent="-342900">
-              <a:spcAft>
-                <a:spcPts val="800"/>
-              </a:spcAft>
-              <a:buSzPct val="100000"/>
-              <a:buChar char="•"/>
-            </a:pPr>
-            <a:r>
-              <a:rPr lang="en-US" sz="1300" dirty="0">
-                <a:solidFill>
-                  <a:schemeClr val="tx1"/>
-                </a:solidFill>
-              </a:rPr>
-              <a:t>Edit CGPA, projects, internships or add skills</a:t>
-            </a:r>
-            <a:endParaRPr lang="en-US" sz="1300" dirty="0"/>
-          </a:p>
-          <a:p>
-            <a:pPr marL="342900" indent="-342900">
-              <a:spcAft>
-                <a:spcPts val="800"/>
-              </a:spcAft>
-              <a:buSzPct val="100000"/>
-              <a:buChar char="•"/>
-            </a:pPr>
-            <a:r>
-              <a:rPr lang="en-US" sz="1300" dirty="0">
-                <a:solidFill>
-                  <a:schemeClr val="tx1"/>
-                </a:solidFill>
-              </a:rPr>
-              <a:t>Probability and alignment recompute instantly</a:t>
-            </a:r>
-            <a:endParaRPr lang="en-US" sz="1300" dirty="0"/>
-          </a:p>
-          <a:p>
-            <a:pPr marL="342900" indent="-342900">
-              <a:spcAft>
-                <a:spcPts val="800"/>
-              </a:spcAft>
-              <a:buSzPct val="100000"/>
-              <a:buChar char="•"/>
-            </a:pPr>
-            <a:r>
-              <a:rPr lang="en-US" sz="1300" dirty="0">
-                <a:solidFill>
-                  <a:schemeClr val="tx1"/>
-                </a:solidFill>
-              </a:rPr>
-              <a:t>Ranks the single most useful skill to learn</a:t>
-            </a:r>
-            <a:endParaRPr lang="en-US" sz="1300" dirty="0"/>
-          </a:p>
-        </p:txBody>
-      </p:sp>
-      <p:sp>
-        <p:nvSpPr>
-          <p:cNvPr id="7" name="Text 4"/>
-          <p:cNvSpPr txBox="1"/>
-          <p:nvPr/>
-        </p:nvSpPr>
-        <p:spPr>
-          <a:xfrm>
-            <a:off x="6217920" y="3931920"/>
-            <a:ext cx="2468880" cy="640080"/>
-          </a:xfrm>
-          <a:prstGeom prst="rect">
-            <a:avLst/>
-          </a:prstGeom>
-          <a:noFill/>
-          <a:ln/>
-        </p:spPr>
-        <p:txBody>
-          <a:bodyPr wrap="square" lIns="0" tIns="0" rIns="0" bIns="0" rtlCol="0" anchor="b"/>
-          <a:lstStyle/>
-          <a:p>
-            <a:pPr indent="0" marL="0">
-              <a:buNone/>
-            </a:pPr>
-            <a:r>
-              <a:rPr lang="en-US" sz="1100" i="1" dirty="0">
+              <a:rPr lang="en-US" sz="1200" dirty="0">
                 <a:solidFill>
                   <a:schemeClr val="accent6"/>
                 </a:solidFill>
               </a:rPr>
-              <a:t>On the real data, adding skills lowers the estimate — the dashboard says so and explains why, rather than hiding it.</a:t>
-            </a:r>
-            <a:endParaRPr lang="en-US" sz="1100" dirty="0"/>
+              <a:t>The next slides show each of these steps in the running dashboard.</a:t>
+            </a:r>
+            <a:endParaRPr lang="en-US" sz="1200" dirty="0"/>
           </a:p>
         </p:txBody>
       </p:sp>
@@ -5931,7 +6049,7 @@
                   <a:schemeClr val="tx2"/>
                 </a:solidFill>
               </a:rPr>
-              <a:t>Dashboard — Cohort analytics</a:t>
+              <a:t>Dashboard — Student 360</a:t>
             </a:r>
             <a:endParaRPr lang="en-US" sz="2800" dirty="0"/>
           </a:p>
@@ -5961,7 +6079,7 @@
       </p:sp>
       <p:pic>
         <p:nvPicPr>
-          <p:cNvPr id="4" name="Image 0" descr="Dashboard — Cohort analytics">    </p:cNvPr>
+          <p:cNvPr id="4" name="Image 0" descr="Dashboard — Student 360">    </p:cNvPr>
           <p:cNvPicPr>
             <a:picLocks noChangeAspect="1"/>
           </p:cNvPicPr>
@@ -6013,7 +6131,7 @@
                   <a:schemeClr val="accent1"/>
                 </a:solidFill>
               </a:rPr>
-              <a:t>Who needs help first</a:t>
+              <a:t>One student, one page</a:t>
             </a:r>
             <a:endParaRPr lang="en-US" sz="1600" dirty="0"/>
           </a:p>
@@ -6053,7 +6171,7 @@
                   <a:schemeClr val="tx1"/>
                 </a:solidFill>
               </a:rPr>
-              <a:t>Distribution of predicted probabilities</a:t>
+              <a:t>Placement probability gauge with risk tier</a:t>
             </a:r>
             <a:endParaRPr lang="en-US" sz="1300" dirty="0"/>
           </a:p>
@@ -6071,7 +6189,7 @@
                   <a:schemeClr val="tx1"/>
                 </a:solidFill>
               </a:rPr>
-              <a:t>Alignment vs outlook for every student</a:t>
+              <a:t>KPIs compared with the cohort median</a:t>
             </a:r>
             <a:endParaRPr lang="en-US" sz="1300" dirty="0"/>
           </a:p>
@@ -6089,7 +6207,7 @@
                   <a:schemeClr val="tx1"/>
                 </a:solidFill>
               </a:rPr>
-              <a:t>Most common gaps across the cohort</a:t>
+              <a:t>Skill-coverage radar vs cohort average</a:t>
             </a:r>
             <a:endParaRPr lang="en-US" sz="1300" dirty="0"/>
           </a:p>
@@ -6107,7 +6225,7 @@
                   <a:schemeClr val="tx1"/>
                 </a:solidFill>
               </a:rPr>
-              <a:t>Downloadable intervention list</a:t>
+              <a:t>Gaps ranked by market demand</a:t>
             </a:r>
             <a:endParaRPr lang="en-US" sz="1300" dirty="0"/>
           </a:p>
@@ -6215,7 +6333,7 @@
                   <a:schemeClr val="tx2"/>
                 </a:solidFill>
               </a:rPr>
-              <a:t>Dashboard — Market pulse</a:t>
+              <a:t>Dashboard — What-if simulator</a:t>
             </a:r>
             <a:endParaRPr lang="en-US" sz="2800" dirty="0"/>
           </a:p>
@@ -6245,7 +6363,7 @@
       </p:sp>
       <p:pic>
         <p:nvPicPr>
-          <p:cNvPr id="4" name="Image 0" descr="Dashboard — Market pulse">    </p:cNvPr>
+          <p:cNvPr id="4" name="Image 0" descr="Dashboard — What-if simulator">    </p:cNvPr>
           <p:cNvPicPr>
             <a:picLocks noChangeAspect="1"/>
           </p:cNvPicPr>
@@ -6297,7 +6415,7 @@
                   <a:schemeClr val="accent1"/>
                 </a:solidFill>
               </a:rPr>
-              <a:t>What employers ask for</a:t>
+              <a:t>Try a change, see the effect</a:t>
             </a:r>
             <a:endParaRPr lang="en-US" sz="1600" dirty="0"/>
           </a:p>
@@ -6337,7 +6455,7 @@
                   <a:schemeClr val="tx1"/>
                 </a:solidFill>
               </a:rPr>
-              <a:t>Top-N skills from 1,500 real postings</a:t>
+              <a:t>Edit CGPA, projects, internships or add skills</a:t>
             </a:r>
             <a:endParaRPr lang="en-US" sz="1300" dirty="0"/>
           </a:p>
@@ -6355,7 +6473,7 @@
                   <a:schemeClr val="tx1"/>
                 </a:solidFill>
               </a:rPr>
-              <a:t>Demand grouped by skill category</a:t>
+              <a:t>Probability and alignment recompute instantly</a:t>
             </a:r>
             <a:endParaRPr lang="en-US" sz="1300" dirty="0"/>
           </a:p>
@@ -6373,9 +6491,45 @@
                   <a:schemeClr val="tx1"/>
                 </a:solidFill>
               </a:rPr>
-              <a:t>Filter by job title (e.g. "Data", "Engineer")</a:t>
+              <a:t>Ranks the single most useful skill to learn</a:t>
             </a:r>
             <a:endParaRPr lang="en-US" sz="1300" dirty="0"/>
+          </a:p>
+        </p:txBody>
+      </p:sp>
+      <p:sp>
+        <p:nvSpPr>
+          <p:cNvPr id="7" name="Text 4"/>
+          <p:cNvSpPr txBox="1"/>
+          <p:nvPr/>
+        </p:nvSpPr>
+        <p:spPr>
+          <a:xfrm>
+            <a:off x="6217920" y="3931920"/>
+            <a:ext cx="2468880" cy="640080"/>
+          </a:xfrm>
+          <a:prstGeom prst="rect">
+            <a:avLst/>
+          </a:prstGeom>
+          <a:noFill/>
+          <a:ln/>
+        </p:spPr>
+        <p:txBody>
+          <a:bodyPr wrap="square" lIns="0" tIns="0" rIns="0" bIns="0" rtlCol="0" anchor="b"/>
+          <a:lstStyle/>
+          <a:p>
+            <a:pPr indent="0" marL="0">
+              <a:buNone/>
+            </a:pPr>
+            <a:r>
+              <a:rPr lang="en-US" sz="1100" i="1" dirty="0">
+                <a:solidFill>
+                  <a:schemeClr val="accent6"/>
+                </a:solidFill>
+              </a:rPr>
+              <a:t>On the real data, adding skills lowers the estimate — the dashboard says so and explains why, rather than hiding it.</a:t>
+            </a:r>
+            <a:endParaRPr lang="en-US" sz="1100" dirty="0"/>
           </a:p>
         </p:txBody>
       </p:sp>
@@ -6481,7 +6635,7 @@
                   <a:schemeClr val="tx2"/>
                 </a:solidFill>
               </a:rPr>
-              <a:t>Orchestration — Apache Airflow</a:t>
+              <a:t>Dashboard — Cohort analytics</a:t>
             </a:r>
             <a:endParaRPr lang="en-US" sz="2800" dirty="0"/>
           </a:p>
@@ -6511,7 +6665,7 @@
       </p:sp>
       <p:pic>
         <p:nvPicPr>
-          <p:cNvPr id="4" name="Image 0" descr="Orchestration — Apache Airflow">    </p:cNvPr>
+          <p:cNvPr id="4" name="Image 0" descr="Dashboard — Cohort analytics">    </p:cNvPr>
           <p:cNvPicPr>
             <a:picLocks noChangeAspect="1"/>
           </p:cNvPicPr>
@@ -6563,7 +6717,7 @@
                   <a:schemeClr val="accent1"/>
                 </a:solidFill>
               </a:rPr>
-              <a:t>One DAG, four tasks</a:t>
+              <a:t>Who needs help first</a:t>
             </a:r>
             <a:endParaRPr lang="en-US" sz="1600" dirty="0"/>
           </a:p>
@@ -6603,7 +6757,7 @@
                   <a:schemeClr val="tx1"/>
                 </a:solidFill>
               </a:rPr>
-              <a:t>ingest → extract → features → train</a:t>
+              <a:t>Distribution of predicted probabilities</a:t>
             </a:r>
             <a:endParaRPr lang="en-US" sz="1300" dirty="0"/>
           </a:p>
@@ -6621,7 +6775,7 @@
                   <a:schemeClr val="tx1"/>
                 </a:solidFill>
               </a:rPr>
-              <a:t>Uses real data when present, synthetic otherwise</a:t>
+              <a:t>Alignment vs outlook for every student</a:t>
             </a:r>
             <a:endParaRPr lang="en-US" sz="1300" dirty="0"/>
           </a:p>
@@ -6639,7 +6793,25 @@
                   <a:schemeClr val="tx1"/>
                 </a:solidFill>
               </a:rPr>
-              <a:t>Verified green on real data, ~33 s per run</a:t>
+              <a:t>Most common gaps across the cohort</a:t>
+            </a:r>
+            <a:endParaRPr lang="en-US" sz="1300" dirty="0"/>
+          </a:p>
+          <a:p>
+            <a:pPr marL="342900" indent="-342900">
+              <a:spcAft>
+                <a:spcPts val="800"/>
+              </a:spcAft>
+              <a:buSzPct val="100000"/>
+              <a:buChar char="•"/>
+            </a:pPr>
+            <a:r>
+              <a:rPr lang="en-US" sz="1300" dirty="0">
+                <a:solidFill>
+                  <a:schemeClr val="tx1"/>
+                </a:solidFill>
+              </a:rPr>
+              <a:t>Downloadable intervention list</a:t>
             </a:r>
             <a:endParaRPr lang="en-US" sz="1300" dirty="0"/>
           </a:p>
@@ -6747,7 +6919,7 @@
                   <a:schemeClr val="tx2"/>
                 </a:solidFill>
               </a:rPr>
-              <a:t>Dashboard — Data Studio</a:t>
+              <a:t>Dashboard — Market pulse</a:t>
             </a:r>
             <a:endParaRPr lang="en-US" sz="2800" dirty="0"/>
           </a:p>
@@ -6777,7 +6949,7 @@
       </p:sp>
       <p:pic>
         <p:nvPicPr>
-          <p:cNvPr id="4" name="Image 0" descr="Dashboard — Data Studio">    </p:cNvPr>
+          <p:cNvPr id="4" name="Image 0" descr="Dashboard — Market pulse">    </p:cNvPr>
           <p:cNvPicPr>
             <a:picLocks noChangeAspect="1"/>
           </p:cNvPicPr>
@@ -6829,7 +7001,7 @@
                   <a:schemeClr val="accent1"/>
                 </a:solidFill>
               </a:rPr>
-              <a:t>Bring your own data</a:t>
+              <a:t>What employers ask for</a:t>
             </a:r>
             <a:endParaRPr lang="en-US" sz="1600" dirty="0"/>
           </a:p>
@@ -6869,7 +7041,7 @@
                   <a:schemeClr val="tx1"/>
                 </a:solidFill>
               </a:rPr>
-              <a:t>Upload postings and student CSVs</a:t>
+              <a:t>Top-N skills from 1,500 real postings</a:t>
             </a:r>
             <a:endParaRPr lang="en-US" sz="1300" dirty="0"/>
           </a:p>
@@ -6887,7 +7059,7 @@
                   <a:schemeClr val="tx1"/>
                 </a:solidFill>
               </a:rPr>
-              <a:t>Validated: columns, numbers, duplicate IDs</a:t>
+              <a:t>Demand grouped by skill category</a:t>
             </a:r>
             <a:endParaRPr lang="en-US" sz="1300" dirty="0"/>
           </a:p>
@@ -6905,7 +7077,7 @@
                   <a:schemeClr val="tx1"/>
                 </a:solidFill>
               </a:rPr>
-              <a:t>Re-runs the pipeline with live progress</a:t>
+              <a:t>Filter by job title (e.g. "Data", "Engineer")</a:t>
             </a:r>
             <a:endParaRPr lang="en-US" sz="1300" dirty="0"/>
           </a:p>
@@ -7013,7 +7185,7 @@
                   <a:schemeClr val="tx2"/>
                 </a:solidFill>
               </a:rPr>
-              <a:t>Testing</a:t>
+              <a:t>Orchestration — Apache Airflow</a:t>
             </a:r>
             <a:endParaRPr lang="en-US" sz="2800" dirty="0"/>
           </a:p>
@@ -7021,14 +7193,60 @@
       </p:sp>
       <p:sp>
         <p:nvSpPr>
-          <p:cNvPr id="3" name="Text 1"/>
+          <p:cNvPr id="3" name="Shape 1"/>
+          <p:cNvSpPr/>
+          <p:nvPr/>
+        </p:nvSpPr>
+        <p:spPr>
+          <a:xfrm>
+            <a:off x="411480" y="1005840"/>
+            <a:ext cx="5577840" cy="3529584"/>
+          </a:xfrm>
+          <a:prstGeom prst="roundRect">
+            <a:avLst>
+              <a:gd name="adj" fmla="val 1554"/>
+            </a:avLst>
+          </a:prstGeom>
+          <a:solidFill>
+            <a:schemeClr val="tx2"/>
+          </a:solidFill>
+          <a:ln/>
+        </p:spPr>
+      </p:sp>
+      <p:pic>
+        <p:nvPicPr>
+          <p:cNvPr id="4" name="Image 0" descr="Orchestration — Apache Airflow">    </p:cNvPr>
+          <p:cNvPicPr>
+            <a:picLocks noChangeAspect="1"/>
+          </p:cNvPicPr>
+          <p:nvPr/>
+        </p:nvPicPr>
+        <p:blipFill>
+          <a:blip r:embed="rId1"/>
+          <a:stretch>
+            <a:fillRect/>
+          </a:stretch>
+        </p:blipFill>
+        <p:spPr>
+          <a:xfrm>
+            <a:off x="457200" y="1051560"/>
+            <a:ext cx="5486400" cy="3429000"/>
+          </a:xfrm>
+          <a:prstGeom prst="rect">
+            <a:avLst/>
+          </a:prstGeom>
+        </p:spPr>
+      </p:pic>
+      <p:sp>
+        <p:nvSpPr>
+          <p:cNvPr id="5" name="Text 2"/>
           <p:cNvSpPr txBox="1"/>
           <p:nvPr/>
         </p:nvSpPr>
         <p:spPr>
           <a:xfrm>
-            <a:off x="457200" y="1188720"/>
-            <a:ext cx="2743200" cy="777240"/>
+            <a:off x="6217920" y="1051560"/>
+            <a:ext cx="2468880" cy="457200"/>
           </a:xfrm>
           <a:prstGeom prst="rect">
             <a:avLst/>
@@ -7044,66 +7262,27 @@
               <a:buNone/>
             </a:pPr>
             <a:r>
-              <a:rPr lang="en-US" sz="5400" b="1" dirty="0">
-                <a:solidFill>
-                  <a:schemeClr val="accent2"/>
-                </a:solidFill>
-                <a:latin typeface="Cambria" pitchFamily="34" charset="0"/>
-                <a:ea typeface="Cambria" pitchFamily="34" charset="-122"/>
-                <a:cs typeface="Cambria" pitchFamily="34" charset="-120"/>
-              </a:rPr>
-              <a:t>31</a:t>
-            </a:r>
-            <a:endParaRPr lang="en-US" sz="5400" dirty="0"/>
-          </a:p>
-        </p:txBody>
-      </p:sp>
-      <p:sp>
-        <p:nvSpPr>
-          <p:cNvPr id="4" name="Text 2"/>
+              <a:rPr lang="en-US" sz="1600" b="1" dirty="0">
+                <a:solidFill>
+                  <a:schemeClr val="accent1"/>
+                </a:solidFill>
+              </a:rPr>
+              <a:t>One DAG, four tasks</a:t>
+            </a:r>
+            <a:endParaRPr lang="en-US" sz="1600" dirty="0"/>
+          </a:p>
+        </p:txBody>
+      </p:sp>
+      <p:sp>
+        <p:nvSpPr>
+          <p:cNvPr id="6" name="Text 3"/>
           <p:cNvSpPr txBox="1"/>
           <p:nvPr/>
         </p:nvSpPr>
         <p:spPr>
           <a:xfrm>
-            <a:off x="457200" y="1965960"/>
-            <a:ext cx="2743200" cy="548640"/>
-          </a:xfrm>
-          <a:prstGeom prst="rect">
-            <a:avLst/>
-          </a:prstGeom>
-          <a:noFill/>
-          <a:ln/>
-        </p:spPr>
-        <p:txBody>
-          <a:bodyPr wrap="square" lIns="0" tIns="0" rIns="0" bIns="0" rtlCol="0" anchor="t"/>
-          <a:lstStyle/>
-          <a:p>
-            <a:pPr indent="0" marL="0">
-              <a:buNone/>
-            </a:pPr>
-            <a:r>
-              <a:rPr lang="en-US" sz="1300" dirty="0">
-                <a:solidFill>
-                  <a:schemeClr val="tx1"/>
-                </a:solidFill>
-              </a:rPr>
-              <a:t>automated tests, all passing on real data</a:t>
-            </a:r>
-            <a:endParaRPr lang="en-US" sz="1300" dirty="0"/>
-          </a:p>
-        </p:txBody>
-      </p:sp>
-      <p:sp>
-        <p:nvSpPr>
-          <p:cNvPr id="5" name="Text 3"/>
-          <p:cNvSpPr txBox="1"/>
-          <p:nvPr/>
-        </p:nvSpPr>
-        <p:spPr>
-          <a:xfrm>
-            <a:off x="3566160" y="1188720"/>
-            <a:ext cx="5120640" cy="3291840"/>
+            <a:off x="6217920" y="1554480"/>
+            <a:ext cx="2468880" cy="2377440"/>
           </a:xfrm>
           <a:prstGeom prst="rect">
             <a:avLst/>
@@ -7123,14 +7302,14 @@
               <a:buChar char="•"/>
             </a:pPr>
             <a:r>
-              <a:rPr lang="en-US" sz="1400" dirty="0">
+              <a:rPr lang="en-US" sz="1300" dirty="0">
                 <a:solidFill>
                   <a:schemeClr val="tx1"/>
                 </a:solidFill>
               </a:rPr>
-              <a:t>NLP extractor: casing, overlaps, empty text, ambiguous short names</a:t>
-            </a:r>
-            <a:endParaRPr lang="en-US" sz="1400" dirty="0"/>
+              <a:t>ingest → extract → features → train</a:t>
+            </a:r>
+            <a:endParaRPr lang="en-US" sz="1300" dirty="0"/>
           </a:p>
           <a:p>
             <a:pPr marL="342900" indent="-342900">
@@ -7141,14 +7320,14 @@
               <a:buChar char="•"/>
             </a:pPr>
             <a:r>
-              <a:rPr lang="en-US" sz="1400" dirty="0">
+              <a:rPr lang="en-US" sz="1300" dirty="0">
                 <a:solidFill>
                   <a:schemeClr val="tx1"/>
                 </a:solidFill>
               </a:rPr>
-              <a:t>Feature store: empty input, students without skills</a:t>
-            </a:r>
-            <a:endParaRPr lang="en-US" sz="1400" dirty="0"/>
+              <a:t>Uses real data when present, synthetic otherwise</a:t>
+            </a:r>
+            <a:endParaRPr lang="en-US" sz="1300" dirty="0"/>
           </a:p>
           <a:p>
             <a:pPr marL="342900" indent="-342900">
@@ -7159,50 +7338,14 @@
               <a:buChar char="•"/>
             </a:pPr>
             <a:r>
-              <a:rPr lang="en-US" sz="1400" dirty="0">
+              <a:rPr lang="en-US" sz="1300" dirty="0">
                 <a:solidFill>
                   <a:schemeClr val="tx1"/>
                 </a:solidFill>
               </a:rPr>
-              <a:t>Upload validation and training guards</a:t>
-            </a:r>
-            <a:endParaRPr lang="en-US" sz="1400" dirty="0"/>
-          </a:p>
-          <a:p>
-            <a:pPr marL="342900" indent="-342900">
-              <a:spcAft>
-                <a:spcPts val="800"/>
-              </a:spcAft>
-              <a:buSzPct val="100000"/>
-              <a:buChar char="•"/>
-            </a:pPr>
-            <a:r>
-              <a:rPr lang="en-US" sz="1400" dirty="0">
-                <a:solidFill>
-                  <a:schemeClr val="tx1"/>
-                </a:solidFill>
-              </a:rPr>
-              <a:t>Kafka message handling and S3 upload (no live services needed)</a:t>
-            </a:r>
-            <a:endParaRPr lang="en-US" sz="1400" dirty="0"/>
-          </a:p>
-          <a:p>
-            <a:pPr marL="342900" indent="-342900">
-              <a:spcAft>
-                <a:spcPts val="800"/>
-              </a:spcAft>
-              <a:buSzPct val="100000"/>
-              <a:buChar char="•"/>
-            </a:pPr>
-            <a:r>
-              <a:rPr lang="en-US" sz="1400" dirty="0">
-                <a:solidFill>
-                  <a:schemeClr val="tx1"/>
-                </a:solidFill>
-              </a:rPr>
-              <a:t>Every dashboard page rendered automatically</a:t>
-            </a:r>
-            <a:endParaRPr lang="en-US" sz="1400" dirty="0"/>
+              <a:t>Verified green on real data, ~33 s per run</a:t>
+            </a:r>
+            <a:endParaRPr lang="en-US" sz="1300" dirty="0"/>
           </a:p>
         </p:txBody>
       </p:sp>
@@ -8152,6 +8295,699 @@
                   <a:schemeClr val="tx2"/>
                 </a:solidFill>
               </a:rPr>
+              <a:t>Dashboard — Data Studio</a:t>
+            </a:r>
+            <a:endParaRPr lang="en-US" sz="2800" dirty="0"/>
+          </a:p>
+        </p:txBody>
+      </p:sp>
+      <p:sp>
+        <p:nvSpPr>
+          <p:cNvPr id="3" name="Shape 1"/>
+          <p:cNvSpPr/>
+          <p:nvPr/>
+        </p:nvSpPr>
+        <p:spPr>
+          <a:xfrm>
+            <a:off x="411480" y="1005840"/>
+            <a:ext cx="5577840" cy="3529584"/>
+          </a:xfrm>
+          <a:prstGeom prst="roundRect">
+            <a:avLst>
+              <a:gd name="adj" fmla="val 1554"/>
+            </a:avLst>
+          </a:prstGeom>
+          <a:solidFill>
+            <a:schemeClr val="tx2"/>
+          </a:solidFill>
+          <a:ln/>
+        </p:spPr>
+      </p:sp>
+      <p:pic>
+        <p:nvPicPr>
+          <p:cNvPr id="4" name="Image 0" descr="Dashboard — Data Studio">    </p:cNvPr>
+          <p:cNvPicPr>
+            <a:picLocks noChangeAspect="1"/>
+          </p:cNvPicPr>
+          <p:nvPr/>
+        </p:nvPicPr>
+        <p:blipFill>
+          <a:blip r:embed="rId1"/>
+          <a:stretch>
+            <a:fillRect/>
+          </a:stretch>
+        </p:blipFill>
+        <p:spPr>
+          <a:xfrm>
+            <a:off x="457200" y="1051560"/>
+            <a:ext cx="5486400" cy="3429000"/>
+          </a:xfrm>
+          <a:prstGeom prst="rect">
+            <a:avLst/>
+          </a:prstGeom>
+        </p:spPr>
+      </p:pic>
+      <p:sp>
+        <p:nvSpPr>
+          <p:cNvPr id="5" name="Text 2"/>
+          <p:cNvSpPr txBox="1"/>
+          <p:nvPr/>
+        </p:nvSpPr>
+        <p:spPr>
+          <a:xfrm>
+            <a:off x="6217920" y="1051560"/>
+            <a:ext cx="2468880" cy="457200"/>
+          </a:xfrm>
+          <a:prstGeom prst="rect">
+            <a:avLst/>
+          </a:prstGeom>
+          <a:noFill/>
+          <a:ln/>
+        </p:spPr>
+        <p:txBody>
+          <a:bodyPr wrap="square" lIns="0" tIns="0" rIns="0" bIns="0" rtlCol="0" anchor="ctr"/>
+          <a:lstStyle/>
+          <a:p>
+            <a:pPr indent="0" marL="0">
+              <a:buNone/>
+            </a:pPr>
+            <a:r>
+              <a:rPr lang="en-US" sz="1600" b="1" dirty="0">
+                <a:solidFill>
+                  <a:schemeClr val="accent1"/>
+                </a:solidFill>
+              </a:rPr>
+              <a:t>Bring your own data</a:t>
+            </a:r>
+            <a:endParaRPr lang="en-US" sz="1600" dirty="0"/>
+          </a:p>
+        </p:txBody>
+      </p:sp>
+      <p:sp>
+        <p:nvSpPr>
+          <p:cNvPr id="6" name="Text 3"/>
+          <p:cNvSpPr txBox="1"/>
+          <p:nvPr/>
+        </p:nvSpPr>
+        <p:spPr>
+          <a:xfrm>
+            <a:off x="6217920" y="1554480"/>
+            <a:ext cx="2468880" cy="2377440"/>
+          </a:xfrm>
+          <a:prstGeom prst="rect">
+            <a:avLst/>
+          </a:prstGeom>
+          <a:noFill/>
+          <a:ln/>
+        </p:spPr>
+        <p:txBody>
+          <a:bodyPr wrap="square" lIns="0" tIns="0" rIns="0" bIns="0" rtlCol="0" anchor="t"/>
+          <a:lstStyle/>
+          <a:p>
+            <a:pPr marL="342900" indent="-342900">
+              <a:spcAft>
+                <a:spcPts val="800"/>
+              </a:spcAft>
+              <a:buSzPct val="100000"/>
+              <a:buChar char="•"/>
+            </a:pPr>
+            <a:r>
+              <a:rPr lang="en-US" sz="1300" dirty="0">
+                <a:solidFill>
+                  <a:schemeClr val="tx1"/>
+                </a:solidFill>
+              </a:rPr>
+              <a:t>Upload postings and student CSVs</a:t>
+            </a:r>
+            <a:endParaRPr lang="en-US" sz="1300" dirty="0"/>
+          </a:p>
+          <a:p>
+            <a:pPr marL="342900" indent="-342900">
+              <a:spcAft>
+                <a:spcPts val="800"/>
+              </a:spcAft>
+              <a:buSzPct val="100000"/>
+              <a:buChar char="•"/>
+            </a:pPr>
+            <a:r>
+              <a:rPr lang="en-US" sz="1300" dirty="0">
+                <a:solidFill>
+                  <a:schemeClr val="tx1"/>
+                </a:solidFill>
+              </a:rPr>
+              <a:t>Validated: columns, numbers, duplicate IDs</a:t>
+            </a:r>
+            <a:endParaRPr lang="en-US" sz="1300" dirty="0"/>
+          </a:p>
+          <a:p>
+            <a:pPr marL="342900" indent="-342900">
+              <a:spcAft>
+                <a:spcPts val="800"/>
+              </a:spcAft>
+              <a:buSzPct val="100000"/>
+              <a:buChar char="•"/>
+            </a:pPr>
+            <a:r>
+              <a:rPr lang="en-US" sz="1300" dirty="0">
+                <a:solidFill>
+                  <a:schemeClr val="tx1"/>
+                </a:solidFill>
+              </a:rPr>
+              <a:t>Re-runs the pipeline with live progress</a:t>
+            </a:r>
+            <a:endParaRPr lang="en-US" sz="1300" dirty="0"/>
+          </a:p>
+        </p:txBody>
+      </p:sp>
+      <p:sp>
+        <p:nvSpPr>
+          <p:cNvPr id="25" name="Slide Number Placeholder 0"/>
+          <p:cNvSpPr>
+            <a:spLocks noGrp="1"/>
+          </p:cNvSpPr>
+          <p:nvPr>
+            <p:ph type="sldNum" sz="quarter" idx="4294967295"/>
+          </p:nvPr>
+        </p:nvSpPr>
+        <p:spPr>
+          <a:xfrm>
+            <a:off x="8229600" y="4754880"/>
+            <a:ext cx="457200" cy="274320"/>
+          </a:xfrm>
+          <a:prstGeom prst="rect">
+            <a:avLst/>
+          </a:prstGeom>
+          <a:extLst>
+            <a:ext uri="{C572A759-6A51-4108-AA02-DFA0A04FC94B}">
+              <ma14:wrappingTextBoxFlag xmlns:ma14="http://schemas.microsoft.com/office/mac/drawingml/2011/main" val="0"/>
+            </a:ext>
+          </a:extLst>
+        </p:spPr>
+        <p:txBody>
+          <a:bodyPr/>
+          <a:lstStyle>
+            <a:lvl1pPr>
+              <a:defRPr sz="1000">
+                <a:solidFill>
+                  <a:schemeClr val="accent6"/>
+                </a:solidFill>
+              </a:defRPr>
+            </a:lvl1pPr>
+          </a:lstStyle>
+          <a:p>
+            <a:pPr algn="r"/>
+            <a:fld id="{F7021451-1387-4CA6-816F-3879F97B5CBC}" type="slidenum">
+              <a:rPr b="0" lang="en-US"/>
+              <a:t>20</a:t>
+            </a:fld>
+            <a:endParaRPr lang="en-US"/>
+          </a:p>
+        </p:txBody>
+      </p:sp>
+    </p:spTree>
+  </p:cSld>
+  <p:clrMapOvr>
+    <a:masterClrMapping/>
+  </p:clrMapOvr>
+</p:sld>
+</file>
+
+<file path=ppt/slides/slide21.xml><?xml version="1.0" encoding="utf-8"?>
+<p:sld xmlns:a="http://schemas.openxmlformats.org/drawingml/2006/main" xmlns:r="http://schemas.openxmlformats.org/officeDocument/2006/relationships" xmlns:p="http://schemas.openxmlformats.org/presentationml/2006/main">
+  <p:cSld name="Slide 21">
+    <p:spTree>
+      <p:nvGrpSpPr>
+        <p:cNvPr id="1" name=""/>
+        <p:cNvGrpSpPr/>
+        <p:nvPr/>
+      </p:nvGrpSpPr>
+      <p:grpSpPr>
+        <a:xfrm>
+          <a:off x="0" y="0"/>
+          <a:ext cx="0" cy="0"/>
+          <a:chOff x="0" y="0"/>
+          <a:chExt cx="0" cy="0"/>
+        </a:xfrm>
+      </p:grpSpPr>
+      <p:sp>
+        <p:nvSpPr>
+          <p:cNvPr id="2" name="Text 0"/>
+          <p:cNvSpPr/>
+          <p:nvPr>
+            <p:ph idx="100" type="title" hasCustomPrompt="1"/>
+          </p:nvPr>
+        </p:nvSpPr>
+        <p:spPr>
+          <a:xfrm>
+            <a:off x="457200" y="274320"/>
+            <a:ext cx="8229600" cy="685800"/>
+          </a:xfrm>
+          <a:prstGeom prst="rect">
+            <a:avLst/>
+          </a:prstGeom>
+          <a:noFill/>
+          <a:ln/>
+        </p:spPr>
+        <p:txBody>
+          <a:bodyPr wrap="square" lIns="0" tIns="0" rIns="0" bIns="0" rtlCol="0" anchor="ctr"/>
+          <a:lstStyle/>
+          <a:p>
+            <a:pPr algn="l" indent="0" marL="0">
+              <a:buNone/>
+            </a:pPr>
+            <a:r>
+              <a:rPr lang="en-US" sz="2800" b="1" dirty="0">
+                <a:solidFill>
+                  <a:schemeClr val="tx2"/>
+                </a:solidFill>
+              </a:rPr>
+              <a:t>Development flow</a:t>
+            </a:r>
+            <a:endParaRPr lang="en-US" sz="2800" dirty="0"/>
+          </a:p>
+        </p:txBody>
+      </p:sp>
+      <p:pic>
+        <p:nvPicPr>
+          <p:cNvPr id="3" name="Image 0" descr="Development flow">    </p:cNvPr>
+          <p:cNvPicPr>
+            <a:picLocks noChangeAspect="1"/>
+          </p:cNvPicPr>
+          <p:nvPr/>
+        </p:nvPicPr>
+        <p:blipFill>
+          <a:blip r:embed="rId1"/>
+          <a:stretch>
+            <a:fillRect/>
+          </a:stretch>
+        </p:blipFill>
+        <p:spPr>
+          <a:xfrm>
+            <a:off x="274320" y="959849"/>
+            <a:ext cx="8595360" cy="3703862"/>
+          </a:xfrm>
+          <a:prstGeom prst="rect">
+            <a:avLst/>
+          </a:prstGeom>
+        </p:spPr>
+      </p:pic>
+      <p:sp>
+        <p:nvSpPr>
+          <p:cNvPr id="25" name="Slide Number Placeholder 0"/>
+          <p:cNvSpPr>
+            <a:spLocks noGrp="1"/>
+          </p:cNvSpPr>
+          <p:nvPr>
+            <p:ph type="sldNum" sz="quarter" idx="4294967295"/>
+          </p:nvPr>
+        </p:nvSpPr>
+        <p:spPr>
+          <a:xfrm>
+            <a:off x="8229600" y="4754880"/>
+            <a:ext cx="457200" cy="274320"/>
+          </a:xfrm>
+          <a:prstGeom prst="rect">
+            <a:avLst/>
+          </a:prstGeom>
+          <a:extLst>
+            <a:ext uri="{C572A759-6A51-4108-AA02-DFA0A04FC94B}">
+              <ma14:wrappingTextBoxFlag xmlns:ma14="http://schemas.microsoft.com/office/mac/drawingml/2011/main" val="0"/>
+            </a:ext>
+          </a:extLst>
+        </p:spPr>
+        <p:txBody>
+          <a:bodyPr/>
+          <a:lstStyle>
+            <a:lvl1pPr>
+              <a:defRPr sz="1000">
+                <a:solidFill>
+                  <a:schemeClr val="accent6"/>
+                </a:solidFill>
+              </a:defRPr>
+            </a:lvl1pPr>
+          </a:lstStyle>
+          <a:p>
+            <a:pPr algn="r"/>
+            <a:fld id="{F7021451-1387-4CA6-816F-3879F97B5CBC}" type="slidenum">
+              <a:rPr b="0" lang="en-US"/>
+              <a:t>21</a:t>
+            </a:fld>
+            <a:endParaRPr lang="en-US"/>
+          </a:p>
+        </p:txBody>
+      </p:sp>
+    </p:spTree>
+  </p:cSld>
+  <p:clrMapOvr>
+    <a:masterClrMapping/>
+  </p:clrMapOvr>
+</p:sld>
+</file>
+
+<file path=ppt/slides/slide22.xml><?xml version="1.0" encoding="utf-8"?>
+<p:sld xmlns:a="http://schemas.openxmlformats.org/drawingml/2006/main" xmlns:r="http://schemas.openxmlformats.org/officeDocument/2006/relationships" xmlns:p="http://schemas.openxmlformats.org/presentationml/2006/main">
+  <p:cSld name="Slide 22">
+    <p:spTree>
+      <p:nvGrpSpPr>
+        <p:cNvPr id="1" name=""/>
+        <p:cNvGrpSpPr/>
+        <p:nvPr/>
+      </p:nvGrpSpPr>
+      <p:grpSpPr>
+        <a:xfrm>
+          <a:off x="0" y="0"/>
+          <a:ext cx="0" cy="0"/>
+          <a:chOff x="0" y="0"/>
+          <a:chExt cx="0" cy="0"/>
+        </a:xfrm>
+      </p:grpSpPr>
+      <p:sp>
+        <p:nvSpPr>
+          <p:cNvPr id="2" name="Text 0"/>
+          <p:cNvSpPr/>
+          <p:nvPr>
+            <p:ph idx="100" type="title" hasCustomPrompt="1"/>
+          </p:nvPr>
+        </p:nvSpPr>
+        <p:spPr>
+          <a:xfrm>
+            <a:off x="457200" y="274320"/>
+            <a:ext cx="8229600" cy="685800"/>
+          </a:xfrm>
+          <a:prstGeom prst="rect">
+            <a:avLst/>
+          </a:prstGeom>
+          <a:noFill/>
+          <a:ln/>
+        </p:spPr>
+        <p:txBody>
+          <a:bodyPr wrap="square" lIns="0" tIns="0" rIns="0" bIns="0" rtlCol="0" anchor="ctr"/>
+          <a:lstStyle/>
+          <a:p>
+            <a:pPr algn="l" indent="0" marL="0">
+              <a:buNone/>
+            </a:pPr>
+            <a:r>
+              <a:rPr lang="en-US" sz="2800" b="1" dirty="0">
+                <a:solidFill>
+                  <a:schemeClr val="tx2"/>
+                </a:solidFill>
+              </a:rPr>
+              <a:t>Testing</a:t>
+            </a:r>
+            <a:endParaRPr lang="en-US" sz="2800" dirty="0"/>
+          </a:p>
+        </p:txBody>
+      </p:sp>
+      <p:sp>
+        <p:nvSpPr>
+          <p:cNvPr id="3" name="Text 1"/>
+          <p:cNvSpPr txBox="1"/>
+          <p:nvPr/>
+        </p:nvSpPr>
+        <p:spPr>
+          <a:xfrm>
+            <a:off x="457200" y="1188720"/>
+            <a:ext cx="2743200" cy="777240"/>
+          </a:xfrm>
+          <a:prstGeom prst="rect">
+            <a:avLst/>
+          </a:prstGeom>
+          <a:noFill/>
+          <a:ln/>
+        </p:spPr>
+        <p:txBody>
+          <a:bodyPr wrap="square" lIns="0" tIns="0" rIns="0" bIns="0" rtlCol="0" anchor="ctr"/>
+          <a:lstStyle/>
+          <a:p>
+            <a:pPr indent="0" marL="0">
+              <a:buNone/>
+            </a:pPr>
+            <a:r>
+              <a:rPr lang="en-US" sz="5400" b="1" dirty="0">
+                <a:solidFill>
+                  <a:schemeClr val="accent2"/>
+                </a:solidFill>
+                <a:latin typeface="Cambria" pitchFamily="34" charset="0"/>
+                <a:ea typeface="Cambria" pitchFamily="34" charset="-122"/>
+                <a:cs typeface="Cambria" pitchFamily="34" charset="-120"/>
+              </a:rPr>
+              <a:t>31</a:t>
+            </a:r>
+            <a:endParaRPr lang="en-US" sz="5400" dirty="0"/>
+          </a:p>
+        </p:txBody>
+      </p:sp>
+      <p:sp>
+        <p:nvSpPr>
+          <p:cNvPr id="4" name="Text 2"/>
+          <p:cNvSpPr txBox="1"/>
+          <p:nvPr/>
+        </p:nvSpPr>
+        <p:spPr>
+          <a:xfrm>
+            <a:off x="457200" y="1965960"/>
+            <a:ext cx="2743200" cy="548640"/>
+          </a:xfrm>
+          <a:prstGeom prst="rect">
+            <a:avLst/>
+          </a:prstGeom>
+          <a:noFill/>
+          <a:ln/>
+        </p:spPr>
+        <p:txBody>
+          <a:bodyPr wrap="square" lIns="0" tIns="0" rIns="0" bIns="0" rtlCol="0" anchor="t"/>
+          <a:lstStyle/>
+          <a:p>
+            <a:pPr indent="0" marL="0">
+              <a:buNone/>
+            </a:pPr>
+            <a:r>
+              <a:rPr lang="en-US" sz="1300" dirty="0">
+                <a:solidFill>
+                  <a:schemeClr val="tx1"/>
+                </a:solidFill>
+              </a:rPr>
+              <a:t>automated tests, all passing on real data</a:t>
+            </a:r>
+            <a:endParaRPr lang="en-US" sz="1300" dirty="0"/>
+          </a:p>
+        </p:txBody>
+      </p:sp>
+      <p:sp>
+        <p:nvSpPr>
+          <p:cNvPr id="5" name="Text 3"/>
+          <p:cNvSpPr txBox="1"/>
+          <p:nvPr/>
+        </p:nvSpPr>
+        <p:spPr>
+          <a:xfrm>
+            <a:off x="3566160" y="1188720"/>
+            <a:ext cx="5120640" cy="3291840"/>
+          </a:xfrm>
+          <a:prstGeom prst="rect">
+            <a:avLst/>
+          </a:prstGeom>
+          <a:noFill/>
+          <a:ln/>
+        </p:spPr>
+        <p:txBody>
+          <a:bodyPr wrap="square" lIns="0" tIns="0" rIns="0" bIns="0" rtlCol="0" anchor="t"/>
+          <a:lstStyle/>
+          <a:p>
+            <a:pPr marL="342900" indent="-342900">
+              <a:spcAft>
+                <a:spcPts val="800"/>
+              </a:spcAft>
+              <a:buSzPct val="100000"/>
+              <a:buChar char="•"/>
+            </a:pPr>
+            <a:r>
+              <a:rPr lang="en-US" sz="1400" dirty="0">
+                <a:solidFill>
+                  <a:schemeClr val="tx1"/>
+                </a:solidFill>
+              </a:rPr>
+              <a:t>NLP extractor: casing, overlaps, empty text, ambiguous short names</a:t>
+            </a:r>
+            <a:endParaRPr lang="en-US" sz="1400" dirty="0"/>
+          </a:p>
+          <a:p>
+            <a:pPr marL="342900" indent="-342900">
+              <a:spcAft>
+                <a:spcPts val="800"/>
+              </a:spcAft>
+              <a:buSzPct val="100000"/>
+              <a:buChar char="•"/>
+            </a:pPr>
+            <a:r>
+              <a:rPr lang="en-US" sz="1400" dirty="0">
+                <a:solidFill>
+                  <a:schemeClr val="tx1"/>
+                </a:solidFill>
+              </a:rPr>
+              <a:t>Feature store: empty input, students without skills</a:t>
+            </a:r>
+            <a:endParaRPr lang="en-US" sz="1400" dirty="0"/>
+          </a:p>
+          <a:p>
+            <a:pPr marL="342900" indent="-342900">
+              <a:spcAft>
+                <a:spcPts val="800"/>
+              </a:spcAft>
+              <a:buSzPct val="100000"/>
+              <a:buChar char="•"/>
+            </a:pPr>
+            <a:r>
+              <a:rPr lang="en-US" sz="1400" dirty="0">
+                <a:solidFill>
+                  <a:schemeClr val="tx1"/>
+                </a:solidFill>
+              </a:rPr>
+              <a:t>Upload validation and training guards</a:t>
+            </a:r>
+            <a:endParaRPr lang="en-US" sz="1400" dirty="0"/>
+          </a:p>
+          <a:p>
+            <a:pPr marL="342900" indent="-342900">
+              <a:spcAft>
+                <a:spcPts val="800"/>
+              </a:spcAft>
+              <a:buSzPct val="100000"/>
+              <a:buChar char="•"/>
+            </a:pPr>
+            <a:r>
+              <a:rPr lang="en-US" sz="1400" dirty="0">
+                <a:solidFill>
+                  <a:schemeClr val="tx1"/>
+                </a:solidFill>
+              </a:rPr>
+              <a:t>Kafka message handling and S3 upload (no live services needed)</a:t>
+            </a:r>
+            <a:endParaRPr lang="en-US" sz="1400" dirty="0"/>
+          </a:p>
+          <a:p>
+            <a:pPr marL="342900" indent="-342900">
+              <a:spcAft>
+                <a:spcPts val="800"/>
+              </a:spcAft>
+              <a:buSzPct val="100000"/>
+              <a:buChar char="•"/>
+            </a:pPr>
+            <a:r>
+              <a:rPr lang="en-US" sz="1400" dirty="0">
+                <a:solidFill>
+                  <a:schemeClr val="tx1"/>
+                </a:solidFill>
+              </a:rPr>
+              <a:t>Every dashboard page rendered automatically</a:t>
+            </a:r>
+            <a:endParaRPr lang="en-US" sz="1400" dirty="0"/>
+          </a:p>
+        </p:txBody>
+      </p:sp>
+      <p:sp>
+        <p:nvSpPr>
+          <p:cNvPr id="25" name="Slide Number Placeholder 0"/>
+          <p:cNvSpPr>
+            <a:spLocks noGrp="1"/>
+          </p:cNvSpPr>
+          <p:nvPr>
+            <p:ph type="sldNum" sz="quarter" idx="4294967295"/>
+          </p:nvPr>
+        </p:nvSpPr>
+        <p:spPr>
+          <a:xfrm>
+            <a:off x="8229600" y="4754880"/>
+            <a:ext cx="457200" cy="274320"/>
+          </a:xfrm>
+          <a:prstGeom prst="rect">
+            <a:avLst/>
+          </a:prstGeom>
+          <a:extLst>
+            <a:ext uri="{C572A759-6A51-4108-AA02-DFA0A04FC94B}">
+              <ma14:wrappingTextBoxFlag xmlns:ma14="http://schemas.microsoft.com/office/mac/drawingml/2011/main" val="0"/>
+            </a:ext>
+          </a:extLst>
+        </p:spPr>
+        <p:txBody>
+          <a:bodyPr/>
+          <a:lstStyle>
+            <a:lvl1pPr>
+              <a:defRPr sz="1000">
+                <a:solidFill>
+                  <a:schemeClr val="accent6"/>
+                </a:solidFill>
+              </a:defRPr>
+            </a:lvl1pPr>
+          </a:lstStyle>
+          <a:p>
+            <a:pPr algn="r"/>
+            <a:fld id="{F7021451-1387-4CA6-816F-3879F97B5CBC}" type="slidenum">
+              <a:rPr b="0" lang="en-US"/>
+              <a:t>22</a:t>
+            </a:fld>
+            <a:endParaRPr lang="en-US"/>
+          </a:p>
+        </p:txBody>
+      </p:sp>
+    </p:spTree>
+  </p:cSld>
+  <p:clrMapOvr>
+    <a:masterClrMapping/>
+  </p:clrMapOvr>
+</p:sld>
+</file>
+
+<file path=ppt/slides/slide23.xml><?xml version="1.0" encoding="utf-8"?>
+<p:sld xmlns:a="http://schemas.openxmlformats.org/drawingml/2006/main" xmlns:r="http://schemas.openxmlformats.org/officeDocument/2006/relationships" xmlns:p="http://schemas.openxmlformats.org/presentationml/2006/main">
+  <p:cSld name="Slide 23">
+    <p:spTree>
+      <p:nvGrpSpPr>
+        <p:cNvPr id="1" name=""/>
+        <p:cNvGrpSpPr/>
+        <p:nvPr/>
+      </p:nvGrpSpPr>
+      <p:grpSpPr>
+        <a:xfrm>
+          <a:off x="0" y="0"/>
+          <a:ext cx="0" cy="0"/>
+          <a:chOff x="0" y="0"/>
+          <a:chExt cx="0" cy="0"/>
+        </a:xfrm>
+      </p:grpSpPr>
+      <p:sp>
+        <p:nvSpPr>
+          <p:cNvPr id="2" name="Text 0"/>
+          <p:cNvSpPr/>
+          <p:nvPr>
+            <p:ph idx="100" type="title" hasCustomPrompt="1"/>
+          </p:nvPr>
+        </p:nvSpPr>
+        <p:spPr>
+          <a:xfrm>
+            <a:off x="457200" y="274320"/>
+            <a:ext cx="8229600" cy="685800"/>
+          </a:xfrm>
+          <a:prstGeom prst="rect">
+            <a:avLst/>
+          </a:prstGeom>
+          <a:noFill/>
+          <a:ln/>
+        </p:spPr>
+        <p:txBody>
+          <a:bodyPr wrap="square" lIns="0" tIns="0" rIns="0" bIns="0" rtlCol="0" anchor="ctr"/>
+          <a:lstStyle/>
+          <a:p>
+            <a:pPr algn="l" indent="0" marL="0">
+              <a:buNone/>
+            </a:pPr>
+            <a:r>
+              <a:rPr lang="en-US" sz="2800" b="1" dirty="0">
+                <a:solidFill>
+                  <a:schemeClr val="tx2"/>
+                </a:solidFill>
+              </a:rPr>
               <a:t>Bugs we found and fixed</a:t>
             </a:r>
             <a:endParaRPr lang="en-US" sz="2800" dirty="0"/>
@@ -8160,7 +8996,7 @@
       </p:sp>
       <p:graphicFrame>
         <p:nvGraphicFramePr>
-          <p:cNvPr id="21" name="Table 0"/>
+          <p:cNvPr id="24" name="Table 0"/>
           <p:cNvGraphicFramePr>
             <a:graphicFrameLocks noGrp="1"/>
           </p:cNvGraphicFramePr>
@@ -9338,7 +10174,7 @@
             <a:pPr algn="r"/>
             <a:fld id="{F7021451-1387-4CA6-816F-3879F97B5CBC}" type="slidenum">
               <a:rPr b="0" lang="en-US"/>
-              <a:t>20</a:t>
+              <a:t>23</a:t>
             </a:fld>
             <a:endParaRPr lang="en-US"/>
           </a:p>
@@ -9352,9 +10188,9 @@
 </p:sld>
 </file>
 
-<file path=ppt/slides/slide21.xml><?xml version="1.0" encoding="utf-8"?>
+<file path=ppt/slides/slide24.xml><?xml version="1.0" encoding="utf-8"?>
 <p:sld xmlns:a="http://schemas.openxmlformats.org/drawingml/2006/main" xmlns:r="http://schemas.openxmlformats.org/officeDocument/2006/relationships" xmlns:p="http://schemas.openxmlformats.org/presentationml/2006/main">
-  <p:cSld name="Slide 21">
+  <p:cSld name="Slide 24">
     <p:spTree>
       <p:nvGrpSpPr>
         <p:cNvPr id="1" name=""/>
@@ -9732,7 +10568,7 @@
             <a:pPr algn="r"/>
             <a:fld id="{F7021451-1387-4CA6-816F-3879F97B5CBC}" type="slidenum">
               <a:rPr b="0" lang="en-US"/>
-              <a:t>21</a:t>
+              <a:t>24</a:t>
             </a:fld>
             <a:endParaRPr lang="en-US"/>
           </a:p>
@@ -9746,9 +10582,9 @@
 </p:sld>
 </file>
 
-<file path=ppt/slides/slide22.xml><?xml version="1.0" encoding="utf-8"?>
+<file path=ppt/slides/slide25.xml><?xml version="1.0" encoding="utf-8"?>
 <p:sld xmlns:a="http://schemas.openxmlformats.org/drawingml/2006/main" xmlns:r="http://schemas.openxmlformats.org/officeDocument/2006/relationships" xmlns:p="http://schemas.openxmlformats.org/presentationml/2006/main">
-  <p:cSld name="Slide 22">
+  <p:cSld name="Slide 25">
     <p:spTree>
       <p:nvGrpSpPr>
         <p:cNvPr id="1" name=""/>
@@ -10326,7 +11162,7 @@
             <a:pPr algn="r"/>
             <a:fld id="{F7021451-1387-4CA6-816F-3879F97B5CBC}" type="slidenum">
               <a:rPr b="0" lang="en-US"/>
-              <a:t>22</a:t>
+              <a:t>25</a:t>
             </a:fld>
             <a:endParaRPr lang="en-US"/>
           </a:p>
@@ -10340,9 +11176,9 @@
 </p:sld>
 </file>
 
-<file path=ppt/slides/slide23.xml><?xml version="1.0" encoding="utf-8"?>
+<file path=ppt/slides/slide26.xml><?xml version="1.0" encoding="utf-8"?>
 <p:sld xmlns:a="http://schemas.openxmlformats.org/drawingml/2006/main" xmlns:r="http://schemas.openxmlformats.org/officeDocument/2006/relationships" xmlns:p="http://schemas.openxmlformats.org/presentationml/2006/main">
-  <p:cSld name="Slide 23">
+  <p:cSld name="Slide 26">
     <p:spTree>
       <p:nvGrpSpPr>
         <p:cNvPr id="1" name=""/>
@@ -12514,7 +13350,7 @@
                   <a:schemeClr val="tx2"/>
                 </a:solidFill>
               </a:rPr>
-              <a:t>System architecture</a:t>
+              <a:t>Project flow</a:t>
             </a:r>
             <a:endParaRPr lang="en-US" sz="2800" dirty="0"/>
           </a:p>
@@ -12522,7 +13358,7 @@
       </p:sp>
       <p:pic>
         <p:nvPicPr>
-          <p:cNvPr id="3" name="Image 0" descr="Architecture diagram">    </p:cNvPr>
+          <p:cNvPr id="3" name="Image 0" descr="Project flow">    </p:cNvPr>
           <p:cNvPicPr>
             <a:picLocks noChangeAspect="1"/>
           </p:cNvPicPr>
@@ -12536,8 +13372,8 @@
         </p:blipFill>
         <p:spPr>
           <a:xfrm>
-            <a:off x="822960" y="1005840"/>
-            <a:ext cx="7498080" cy="3127248"/>
+            <a:off x="1243254" y="914400"/>
+            <a:ext cx="6657491" cy="3520440"/>
           </a:xfrm>
           <a:prstGeom prst="rect">
             <a:avLst/>
@@ -12552,8 +13388,8 @@
         </p:nvSpPr>
         <p:spPr>
           <a:xfrm>
-            <a:off x="457200" y="4206240"/>
-            <a:ext cx="8229600" cy="365760"/>
+            <a:off x="457200" y="4407408"/>
+            <a:ext cx="8229600" cy="320040"/>
           </a:xfrm>
           <a:prstGeom prst="rect">
             <a:avLst/>
@@ -12569,14 +13405,14 @@
               <a:buNone/>
             </a:pPr>
             <a:r>
-              <a:rPr lang="en-US" sz="1300" dirty="0">
+              <a:rPr lang="en-US" sz="1200" dirty="0">
                 <a:solidFill>
                   <a:schemeClr val="accent6"/>
                 </a:solidFill>
               </a:rPr>
-              <a:t>Each stage reads the previous stage's output — every stage runs and is tested on its own.</a:t>
-            </a:r>
-            <a:endParaRPr lang="en-US" sz="1300" dirty="0"/>
+              <a:t>Each stage reads the previous stage's output; Airflow runs the four stages in order.</a:t>
+            </a:r>
+            <a:endParaRPr lang="en-US" sz="1200" dirty="0"/>
           </a:p>
         </p:txBody>
       </p:sp>
@@ -14301,22 +15137,82 @@
                   <a:schemeClr val="tx2"/>
                 </a:solidFill>
               </a:rPr>
-              <a:t>Skill extraction (NLP)</a:t>
+              <a:t>Tech stack flow</a:t>
             </a:r>
             <a:endParaRPr lang="en-US" sz="2800" dirty="0"/>
           </a:p>
         </p:txBody>
       </p:sp>
-      <p:sp>
-        <p:nvSpPr>
-          <p:cNvPr id="3" name="Text 1"/>
+      <p:pic>
+        <p:nvPicPr>
+          <p:cNvPr id="3" name="Image 0" descr="Tech stack flow">    </p:cNvPr>
+          <p:cNvPicPr>
+            <a:picLocks noChangeAspect="1"/>
+          </p:cNvPicPr>
+          <p:nvPr/>
+        </p:nvPicPr>
+        <p:blipFill>
+          <a:blip r:embed="rId1"/>
+          <a:stretch>
+            <a:fillRect/>
+          </a:stretch>
+        </p:blipFill>
+        <p:spPr>
+          <a:xfrm>
+            <a:off x="580519" y="914400"/>
+            <a:ext cx="4508241" cy="3794760"/>
+          </a:xfrm>
+          <a:prstGeom prst="rect">
+            <a:avLst/>
+          </a:prstGeom>
+        </p:spPr>
+      </p:pic>
+      <p:sp>
+        <p:nvSpPr>
+          <p:cNvPr id="4" name="Text 1"/>
           <p:cNvSpPr txBox="1"/>
           <p:nvPr/>
         </p:nvSpPr>
         <p:spPr>
           <a:xfrm>
-            <a:off x="457200" y="1143000"/>
-            <a:ext cx="4663440" cy="3291840"/>
+            <a:off x="5669280" y="1051560"/>
+            <a:ext cx="3017520" cy="411480"/>
+          </a:xfrm>
+          <a:prstGeom prst="rect">
+            <a:avLst/>
+          </a:prstGeom>
+          <a:noFill/>
+          <a:ln/>
+        </p:spPr>
+        <p:txBody>
+          <a:bodyPr wrap="square" lIns="0" tIns="0" rIns="0" bIns="0" rtlCol="0" anchor="ctr"/>
+          <a:lstStyle/>
+          <a:p>
+            <a:pPr indent="0" marL="0">
+              <a:buNone/>
+            </a:pPr>
+            <a:r>
+              <a:rPr lang="en-US" sz="1600" b="1" dirty="0">
+                <a:solidFill>
+                  <a:schemeClr val="accent1"/>
+                </a:solidFill>
+              </a:rPr>
+              <a:t>Read top to bottom</a:t>
+            </a:r>
+            <a:endParaRPr lang="en-US" sz="1600" dirty="0"/>
+          </a:p>
+        </p:txBody>
+      </p:sp>
+      <p:sp>
+        <p:nvSpPr>
+          <p:cNvPr id="5" name="Text 2"/>
+          <p:cNvSpPr txBox="1"/>
+          <p:nvPr/>
+        </p:nvSpPr>
+        <p:spPr>
+          <a:xfrm>
+            <a:off x="5669280" y="1554480"/>
+            <a:ext cx="3017520" cy="2926080"/>
           </a:xfrm>
           <a:prstGeom prst="rect">
             <a:avLst/>
@@ -14336,14 +15232,14 @@
               <a:buChar char="•"/>
             </a:pPr>
             <a:r>
-              <a:rPr lang="en-US" sz="1500" dirty="0">
+              <a:rPr lang="en-US" sz="1300" dirty="0">
                 <a:solidFill>
                   <a:schemeClr val="tx1"/>
                 </a:solidFill>
               </a:rPr>
-              <a:t>Taxonomy of ~150 skills in 8 categories</a:t>
-            </a:r>
-            <a:endParaRPr lang="en-US" sz="1500" dirty="0"/>
+              <a:t>Each layer feeds the one below it</a:t>
+            </a:r>
+            <a:endParaRPr lang="en-US" sz="1300" dirty="0"/>
           </a:p>
           <a:p>
             <a:pPr marL="342900" indent="-342900">
@@ -14354,14 +15250,14 @@
               <a:buChar char="•"/>
             </a:pPr>
             <a:r>
-              <a:rPr lang="en-US" sz="1500" dirty="0">
+              <a:rPr lang="en-US" sz="1300" dirty="0">
                 <a:solidFill>
                   <a:schemeClr val="tx1"/>
                 </a:solidFill>
               </a:rPr>
-              <a:t>Case-insensitive matching, except Go, C, R — stops "go above and beyond" being read as the Go language</a:t>
-            </a:r>
-            <a:endParaRPr lang="en-US" sz="1500" dirty="0"/>
+              <a:t>Kafka, Elasticsearch and Airflow run in Docker</a:t>
+            </a:r>
+            <a:endParaRPr lang="en-US" sz="1300" dirty="0"/>
           </a:p>
           <a:p>
             <a:pPr marL="342900" indent="-342900">
@@ -14372,14 +15268,14 @@
               <a:buChar char="•"/>
             </a:pPr>
             <a:r>
-              <a:rPr lang="en-US" sz="1500" dirty="0">
+              <a:rPr lang="en-US" sz="1300" dirty="0">
                 <a:solidFill>
                   <a:schemeClr val="tx1"/>
                 </a:solidFill>
               </a:rPr>
-              <a:t>Overlapping matches keep the longest span: "AWS Certified Solutions Architect" is not also counted as "AWS"</a:t>
-            </a:r>
-            <a:endParaRPr lang="en-US" sz="1500" dirty="0"/>
+              <a:t>ML library versions pinned so models trained in Airflow load in the dashboard</a:t>
+            </a:r>
+            <a:endParaRPr lang="en-US" sz="1300" dirty="0"/>
           </a:p>
           <a:p>
             <a:pPr marL="342900" indent="-342900">
@@ -14390,184 +15286,12 @@
               <a:buChar char="•"/>
             </a:pPr>
             <a:r>
-              <a:rPr lang="en-US" sz="1500" dirty="0">
+              <a:rPr lang="en-US" sz="1300" dirty="0">
                 <a:solidFill>
                   <a:schemeClr val="tx1"/>
                 </a:solidFill>
               </a:rPr>
-              <a:t>Same function runs in batch and on each Kafka message</a:t>
-            </a:r>
-            <a:endParaRPr lang="en-US" sz="1500" dirty="0"/>
-          </a:p>
-        </p:txBody>
-      </p:sp>
-      <p:sp>
-        <p:nvSpPr>
-          <p:cNvPr id="4" name="Shape 2"/>
-          <p:cNvSpPr/>
-          <p:nvPr/>
-        </p:nvSpPr>
-        <p:spPr>
-          <a:xfrm>
-            <a:off x="5486400" y="1143000"/>
-            <a:ext cx="3200400" cy="3291840"/>
-          </a:xfrm>
-          <a:prstGeom prst="roundRect">
-            <a:avLst>
-              <a:gd name="adj" fmla="val 3429"/>
-            </a:avLst>
-          </a:prstGeom>
-          <a:solidFill>
-            <a:schemeClr val="bg2"/>
-          </a:solidFill>
-          <a:ln/>
-        </p:spPr>
-      </p:sp>
-      <p:sp>
-        <p:nvSpPr>
-          <p:cNvPr id="5" name="Text 3"/>
-          <p:cNvSpPr txBox="1"/>
-          <p:nvPr/>
-        </p:nvSpPr>
-        <p:spPr>
-          <a:xfrm>
-            <a:off x="5760720" y="1325880"/>
-            <a:ext cx="2743200" cy="777240"/>
-          </a:xfrm>
-          <a:prstGeom prst="rect">
-            <a:avLst/>
-          </a:prstGeom>
-          <a:noFill/>
-          <a:ln/>
-        </p:spPr>
-        <p:txBody>
-          <a:bodyPr wrap="square" lIns="0" tIns="0" rIns="0" bIns="0" rtlCol="0" anchor="ctr"/>
-          <a:lstStyle/>
-          <a:p>
-            <a:pPr indent="0" marL="0">
-              <a:buNone/>
-            </a:pPr>
-            <a:r>
-              <a:rPr lang="en-US" sz="4000" b="1" dirty="0">
-                <a:solidFill>
-                  <a:schemeClr val="accent2"/>
-                </a:solidFill>
-                <a:latin typeface="Cambria" pitchFamily="34" charset="0"/>
-                <a:ea typeface="Cambria" pitchFamily="34" charset="-122"/>
-                <a:cs typeface="Cambria" pitchFamily="34" charset="-120"/>
-              </a:rPr>
-              <a:t>99.2%</a:t>
-            </a:r>
-            <a:endParaRPr lang="en-US" sz="4000" dirty="0"/>
-          </a:p>
-        </p:txBody>
-      </p:sp>
-      <p:sp>
-        <p:nvSpPr>
-          <p:cNvPr id="6" name="Text 4"/>
-          <p:cNvSpPr txBox="1"/>
-          <p:nvPr/>
-        </p:nvSpPr>
-        <p:spPr>
-          <a:xfrm>
-            <a:off x="5760720" y="2103120"/>
-            <a:ext cx="2743200" cy="548640"/>
-          </a:xfrm>
-          <a:prstGeom prst="rect">
-            <a:avLst/>
-          </a:prstGeom>
-          <a:noFill/>
-          <a:ln/>
-        </p:spPr>
-        <p:txBody>
-          <a:bodyPr wrap="square" lIns="0" tIns="0" rIns="0" bIns="0" rtlCol="0" anchor="t"/>
-          <a:lstStyle/>
-          <a:p>
-            <a:pPr indent="0" marL="0">
-              <a:buNone/>
-            </a:pPr>
-            <a:r>
-              <a:rPr lang="en-US" sz="1300" dirty="0">
-                <a:solidFill>
-                  <a:schemeClr val="tx1"/>
-                </a:solidFill>
-              </a:rPr>
-              <a:t>precision (up from 84.5% after our fixes)</a:t>
-            </a:r>
-            <a:endParaRPr lang="en-US" sz="1300" dirty="0"/>
-          </a:p>
-        </p:txBody>
-      </p:sp>
-      <p:sp>
-        <p:nvSpPr>
-          <p:cNvPr id="7" name="Text 5"/>
-          <p:cNvSpPr txBox="1"/>
-          <p:nvPr/>
-        </p:nvSpPr>
-        <p:spPr>
-          <a:xfrm>
-            <a:off x="5760720" y="2788920"/>
-            <a:ext cx="2743200" cy="777240"/>
-          </a:xfrm>
-          <a:prstGeom prst="rect">
-            <a:avLst/>
-          </a:prstGeom>
-          <a:noFill/>
-          <a:ln/>
-        </p:spPr>
-        <p:txBody>
-          <a:bodyPr wrap="square" lIns="0" tIns="0" rIns="0" bIns="0" rtlCol="0" anchor="ctr"/>
-          <a:lstStyle/>
-          <a:p>
-            <a:pPr indent="0" marL="0">
-              <a:buNone/>
-            </a:pPr>
-            <a:r>
-              <a:rPr lang="en-US" sz="4000" b="1" dirty="0">
-                <a:solidFill>
-                  <a:schemeClr val="accent1"/>
-                </a:solidFill>
-                <a:latin typeface="Cambria" pitchFamily="34" charset="0"/>
-                <a:ea typeface="Cambria" pitchFamily="34" charset="-122"/>
-                <a:cs typeface="Cambria" pitchFamily="34" charset="-120"/>
-              </a:rPr>
-              <a:t>99.7%</a:t>
-            </a:r>
-            <a:endParaRPr lang="en-US" sz="4000" dirty="0"/>
-          </a:p>
-        </p:txBody>
-      </p:sp>
-      <p:sp>
-        <p:nvSpPr>
-          <p:cNvPr id="8" name="Text 6"/>
-          <p:cNvSpPr txBox="1"/>
-          <p:nvPr/>
-        </p:nvSpPr>
-        <p:spPr>
-          <a:xfrm>
-            <a:off x="5760720" y="3566160"/>
-            <a:ext cx="2743200" cy="548640"/>
-          </a:xfrm>
-          <a:prstGeom prst="rect">
-            <a:avLst/>
-          </a:prstGeom>
-          <a:noFill/>
-          <a:ln/>
-        </p:spPr>
-        <p:txBody>
-          <a:bodyPr wrap="square" lIns="0" tIns="0" rIns="0" bIns="0" rtlCol="0" anchor="t"/>
-          <a:lstStyle/>
-          <a:p>
-            <a:pPr indent="0" marL="0">
-              <a:buNone/>
-            </a:pPr>
-            <a:r>
-              <a:rPr lang="en-US" sz="1300" dirty="0">
-                <a:solidFill>
-                  <a:schemeClr val="tx1"/>
-                </a:solidFill>
-              </a:rPr>
-              <a:t>recall, on synthetic postings with ground truth</a:t>
+              <a:t>31 pytest tests guard every layer</a:t>
             </a:r>
             <a:endParaRPr lang="en-US" sz="1300" dirty="0"/>
           </a:p>
@@ -14675,7 +15399,7 @@
                   <a:schemeClr val="tx2"/>
                 </a:solidFill>
               </a:rPr>
-              <a:t>Market demand &amp; alignment score</a:t>
+              <a:t>Skill extraction (NLP)</a:t>
             </a:r>
             <a:endParaRPr lang="en-US" sz="2800" dirty="0"/>
           </a:p>
@@ -14683,18 +15407,112 @@
       </p:sp>
       <p:sp>
         <p:nvSpPr>
-          <p:cNvPr id="3" name="Shape 1"/>
+          <p:cNvPr id="3" name="Text 1"/>
+          <p:cNvSpPr txBox="1"/>
+          <p:nvPr/>
+        </p:nvSpPr>
+        <p:spPr>
+          <a:xfrm>
+            <a:off x="457200" y="1143000"/>
+            <a:ext cx="4663440" cy="3291840"/>
+          </a:xfrm>
+          <a:prstGeom prst="rect">
+            <a:avLst/>
+          </a:prstGeom>
+          <a:noFill/>
+          <a:ln/>
+        </p:spPr>
+        <p:txBody>
+          <a:bodyPr wrap="square" lIns="0" tIns="0" rIns="0" bIns="0" rtlCol="0" anchor="t"/>
+          <a:lstStyle/>
+          <a:p>
+            <a:pPr marL="342900" indent="-342900">
+              <a:spcAft>
+                <a:spcPts val="800"/>
+              </a:spcAft>
+              <a:buSzPct val="100000"/>
+              <a:buChar char="•"/>
+            </a:pPr>
+            <a:r>
+              <a:rPr lang="en-US" sz="1500" dirty="0">
+                <a:solidFill>
+                  <a:schemeClr val="tx1"/>
+                </a:solidFill>
+              </a:rPr>
+              <a:t>Taxonomy of ~150 skills in 8 categories</a:t>
+            </a:r>
+            <a:endParaRPr lang="en-US" sz="1500" dirty="0"/>
+          </a:p>
+          <a:p>
+            <a:pPr marL="342900" indent="-342900">
+              <a:spcAft>
+                <a:spcPts val="800"/>
+              </a:spcAft>
+              <a:buSzPct val="100000"/>
+              <a:buChar char="•"/>
+            </a:pPr>
+            <a:r>
+              <a:rPr lang="en-US" sz="1500" dirty="0">
+                <a:solidFill>
+                  <a:schemeClr val="tx1"/>
+                </a:solidFill>
+              </a:rPr>
+              <a:t>Case-insensitive matching, except Go, C, R — stops "go above and beyond" being read as the Go language</a:t>
+            </a:r>
+            <a:endParaRPr lang="en-US" sz="1500" dirty="0"/>
+          </a:p>
+          <a:p>
+            <a:pPr marL="342900" indent="-342900">
+              <a:spcAft>
+                <a:spcPts val="800"/>
+              </a:spcAft>
+              <a:buSzPct val="100000"/>
+              <a:buChar char="•"/>
+            </a:pPr>
+            <a:r>
+              <a:rPr lang="en-US" sz="1500" dirty="0">
+                <a:solidFill>
+                  <a:schemeClr val="tx1"/>
+                </a:solidFill>
+              </a:rPr>
+              <a:t>Overlapping matches keep the longest span: "AWS Certified Solutions Architect" is not also counted as "AWS"</a:t>
+            </a:r>
+            <a:endParaRPr lang="en-US" sz="1500" dirty="0"/>
+          </a:p>
+          <a:p>
+            <a:pPr marL="342900" indent="-342900">
+              <a:spcAft>
+                <a:spcPts val="800"/>
+              </a:spcAft>
+              <a:buSzPct val="100000"/>
+              <a:buChar char="•"/>
+            </a:pPr>
+            <a:r>
+              <a:rPr lang="en-US" sz="1500" dirty="0">
+                <a:solidFill>
+                  <a:schemeClr val="tx1"/>
+                </a:solidFill>
+              </a:rPr>
+              <a:t>Same function runs in batch and on each Kafka message</a:t>
+            </a:r>
+            <a:endParaRPr lang="en-US" sz="1500" dirty="0"/>
+          </a:p>
+        </p:txBody>
+      </p:sp>
+      <p:sp>
+        <p:nvSpPr>
+          <p:cNvPr id="4" name="Shape 2"/>
           <p:cNvSpPr/>
           <p:nvPr/>
         </p:nvSpPr>
         <p:spPr>
           <a:xfrm>
-            <a:off x="457200" y="1143000"/>
-            <a:ext cx="3566160" cy="3337560"/>
+            <a:off x="5486400" y="1143000"/>
+            <a:ext cx="3200400" cy="3291840"/>
           </a:xfrm>
           <a:prstGeom prst="roundRect">
             <a:avLst>
-              <a:gd name="adj" fmla="val 3288"/>
+              <a:gd name="adj" fmla="val 3429"/>
             </a:avLst>
           </a:prstGeom>
           <a:solidFill>
@@ -14705,14 +15523,14 @@
       </p:sp>
       <p:sp>
         <p:nvSpPr>
-          <p:cNvPr id="4" name="Text 2"/>
+          <p:cNvPr id="5" name="Text 3"/>
           <p:cNvSpPr txBox="1"/>
           <p:nvPr/>
         </p:nvSpPr>
         <p:spPr>
           <a:xfrm>
-            <a:off x="685800" y="1325880"/>
-            <a:ext cx="3154680" cy="3017520"/>
+            <a:off x="5760720" y="1325880"/>
+            <a:ext cx="2743200" cy="777240"/>
           </a:xfrm>
           <a:prstGeom prst="rect">
             <a:avLst/>
@@ -14721,22 +15539,47 @@
           <a:ln/>
         </p:spPr>
         <p:txBody>
-          <a:bodyPr wrap="square" lIns="0" tIns="0" rIns="0" bIns="0" rtlCol="0" anchor="t"/>
+          <a:bodyPr wrap="square" lIns="0" tIns="0" rIns="0" bIns="0" rtlCol="0" anchor="ctr"/>
           <a:lstStyle/>
           <a:p>
             <a:pPr indent="0" marL="0">
               <a:buNone/>
             </a:pPr>
             <a:r>
-              <a:rPr lang="en-US" sz="1300" b="1" dirty="0">
-                <a:solidFill>
-                  <a:schemeClr val="accent1"/>
-                </a:solidFill>
-              </a:rPr>
-              <a:t>Demand of a skill</a:t>
-            </a:r>
-            <a:endParaRPr lang="en-US" sz="1300" dirty="0"/>
-          </a:p>
+              <a:rPr lang="en-US" sz="4000" b="1" dirty="0">
+                <a:solidFill>
+                  <a:schemeClr val="accent2"/>
+                </a:solidFill>
+                <a:latin typeface="Cambria" pitchFamily="34" charset="0"/>
+                <a:ea typeface="Cambria" pitchFamily="34" charset="-122"/>
+                <a:cs typeface="Cambria" pitchFamily="34" charset="-120"/>
+              </a:rPr>
+              <a:t>99.2%</a:t>
+            </a:r>
+            <a:endParaRPr lang="en-US" sz="4000" dirty="0"/>
+          </a:p>
+        </p:txBody>
+      </p:sp>
+      <p:sp>
+        <p:nvSpPr>
+          <p:cNvPr id="6" name="Text 4"/>
+          <p:cNvSpPr txBox="1"/>
+          <p:nvPr/>
+        </p:nvSpPr>
+        <p:spPr>
+          <a:xfrm>
+            <a:off x="5760720" y="2103120"/>
+            <a:ext cx="2743200" cy="548640"/>
+          </a:xfrm>
+          <a:prstGeom prst="rect">
+            <a:avLst/>
+          </a:prstGeom>
+          <a:noFill/>
+          <a:ln/>
+        </p:spPr>
+        <p:txBody>
+          <a:bodyPr wrap="square" lIns="0" tIns="0" rIns="0" bIns="0" rtlCol="0" anchor="t"/>
+          <a:lstStyle/>
           <a:p>
             <a:pPr indent="0" marL="0">
               <a:buNone/>
@@ -14747,98 +15590,87 @@
                   <a:schemeClr val="tx1"/>
                 </a:solidFill>
               </a:rPr>
-              <a:t>d(s) = postings mentioning s ÷ all postings</a:t>
+              <a:t>precision (up from 84.5% after our fixes)</a:t>
             </a:r>
             <a:endParaRPr lang="en-US" sz="1300" dirty="0"/>
           </a:p>
+        </p:txBody>
+      </p:sp>
+      <p:sp>
+        <p:nvSpPr>
+          <p:cNvPr id="7" name="Text 5"/>
+          <p:cNvSpPr txBox="1"/>
+          <p:nvPr/>
+        </p:nvSpPr>
+        <p:spPr>
+          <a:xfrm>
+            <a:off x="5760720" y="2788920"/>
+            <a:ext cx="2743200" cy="777240"/>
+          </a:xfrm>
+          <a:prstGeom prst="rect">
+            <a:avLst/>
+          </a:prstGeom>
+          <a:noFill/>
+          <a:ln/>
+        </p:spPr>
+        <p:txBody>
+          <a:bodyPr wrap="square" lIns="0" tIns="0" rIns="0" bIns="0" rtlCol="0" anchor="ctr"/>
+          <a:lstStyle/>
           <a:p>
             <a:pPr indent="0" marL="0">
               <a:buNone/>
             </a:pPr>
             <a:r>
-              <a:rPr lang="en-US" sz="1300" dirty="0">
-                <a:solidFill>
-                  <a:schemeClr val="tx1"/>
-                </a:solidFill>
-              </a:rPr>
-              <a:t> </a:t>
-            </a:r>
-            <a:endParaRPr lang="en-US" sz="1300" dirty="0"/>
-          </a:p>
+              <a:rPr lang="en-US" sz="4000" b="1" dirty="0">
+                <a:solidFill>
+                  <a:schemeClr val="accent1"/>
+                </a:solidFill>
+                <a:latin typeface="Cambria" pitchFamily="34" charset="0"/>
+                <a:ea typeface="Cambria" pitchFamily="34" charset="-122"/>
+                <a:cs typeface="Cambria" pitchFamily="34" charset="-120"/>
+              </a:rPr>
+              <a:t>99.7%</a:t>
+            </a:r>
+            <a:endParaRPr lang="en-US" sz="4000" dirty="0"/>
+          </a:p>
+        </p:txBody>
+      </p:sp>
+      <p:sp>
+        <p:nvSpPr>
+          <p:cNvPr id="8" name="Text 6"/>
+          <p:cNvSpPr txBox="1"/>
+          <p:nvPr/>
+        </p:nvSpPr>
+        <p:spPr>
+          <a:xfrm>
+            <a:off x="5760720" y="3566160"/>
+            <a:ext cx="2743200" cy="548640"/>
+          </a:xfrm>
+          <a:prstGeom prst="rect">
+            <a:avLst/>
+          </a:prstGeom>
+          <a:noFill/>
+          <a:ln/>
+        </p:spPr>
+        <p:txBody>
+          <a:bodyPr wrap="square" lIns="0" tIns="0" rIns="0" bIns="0" rtlCol="0" anchor="t"/>
+          <a:lstStyle/>
           <a:p>
             <a:pPr indent="0" marL="0">
               <a:buNone/>
             </a:pPr>
             <a:r>
-              <a:rPr lang="en-US" sz="1300" b="1" dirty="0">
-                <a:solidFill>
-                  <a:schemeClr val="accent1"/>
-                </a:solidFill>
-              </a:rPr>
-              <a:t>Student alignment</a:t>
+              <a:rPr lang="en-US" sz="1300" dirty="0">
+                <a:solidFill>
+                  <a:schemeClr val="tx1"/>
+                </a:solidFill>
+              </a:rPr>
+              <a:t>recall, on synthetic postings with ground truth</a:t>
             </a:r>
             <a:endParaRPr lang="en-US" sz="1300" dirty="0"/>
           </a:p>
-          <a:p>
-            <a:pPr indent="0" marL="0">
-              <a:buNone/>
-            </a:pPr>
-            <a:r>
-              <a:rPr lang="en-US" sz="1300" dirty="0">
-                <a:solidFill>
-                  <a:schemeClr val="tx1"/>
-                </a:solidFill>
-              </a:rPr>
-              <a:t>A(u) = Σ d(s) over the student's skills ÷ Σ d(s) over all skills</a:t>
-            </a:r>
-            <a:endParaRPr lang="en-US" sz="1300" dirty="0"/>
-          </a:p>
-          <a:p>
-            <a:pPr indent="0" marL="0">
-              <a:buNone/>
-            </a:pPr>
-            <a:r>
-              <a:rPr lang="en-US" sz="1300" dirty="0">
-                <a:solidFill>
-                  <a:schemeClr val="tx1"/>
-                </a:solidFill>
-              </a:rPr>
-              <a:t> </a:t>
-            </a:r>
-            <a:endParaRPr lang="en-US" sz="1300" dirty="0"/>
-          </a:p>
-          <a:p>
-            <a:pPr indent="0" marL="0">
-              <a:buNone/>
-            </a:pPr>
-            <a:r>
-              <a:rPr lang="en-US" sz="1300" i="1" dirty="0">
-                <a:solidFill>
-                  <a:schemeClr val="tx1"/>
-                </a:solidFill>
-              </a:rPr>
-              <a:t>0 = covers nothing employers ask for, 1 = covers everything. Gaps are ranked by d(s).</a:t>
-            </a:r>
-            <a:endParaRPr lang="en-US" sz="1300" dirty="0"/>
-          </a:p>
-        </p:txBody>
-      </p:sp>
-      <p:graphicFrame>
-        <p:nvGraphicFramePr>
-          <p:cNvPr id="5" name="Chart 0" descr=""/>
-          <p:cNvGraphicFramePr/>
-          <p:nvPr/>
-        </p:nvGraphicFramePr>
-        <p:xfrm>
-          <a:off x="4206240" y="1051560"/>
-          <a:ext cx="4480560" cy="3474720"/>
-        </p:xfrm>
-        <a:graphic xmlns:a="http://schemas.openxmlformats.org/drawingml/2006/main">
-          <a:graphicData uri="http://schemas.openxmlformats.org/drawingml/2006/chart">
-            <c:chart xmlns:c="http://schemas.openxmlformats.org/drawingml/2006/chart" r:id="rId1"/>
-          </a:graphicData>
-        </a:graphic>
-      </p:graphicFrame>
+        </p:txBody>
+      </p:sp>
       <p:sp>
         <p:nvSpPr>
           <p:cNvPr id="25" name="Slide Number Placeholder 0"/>

</xml_diff>